<commit_message>
docs(61): RU 개정(P95·로그 사다리) + composite 정본 교체(FIN 500건) 동기화 — md·PPT
24 §2 개정과 63 신설 반영: RU 판정 = r P95, 별점 = 로그(데케이드) 사다리(선형 등분의
지수 도메인 포화 근거 병기). 분업 표를 3행(composite = FC·RU·TB, SC는 축 수 스윕
별도)으로 정정, seq2/pool 소개 갱신. FC·TB 슬라이드에 composite 실측 병기(FC 0.941
vs 0.880 / TB pool ★2 vs seq2 ★0 결함 152), RU 스냅샷 전면 교체(seq2 ★3 vs pool
★1·초과 11건·16축 조건부), SC에 FIN 참고 관측(seq2 만점권·pool 실질 16축).
스코어카드 확장 + 읽는 법에 방안 2+(62)·조건부 pool(63) 연결. PPT 재생성.

Co-Authored-By: Claude Fable 5 <noreply@anthropic.com>
</commit_message>
<xml_diff>
--- a/docs/changbae/61-핵심QA-5종-임원-브리핑.pptx
+++ b/docs/changbae/61-핵심QA-5종-임원-브리핑.pptx
@@ -579,7 +579,7 @@
           <a:lstStyle/>
           <a:p>
             <a:r>
-              <a:t>한도 유도: 플래그십 단말 전형의 앱 힙 상한 256MB × 75%(GC 성능 여유) − 64MB(협상 외 앱 기본 점유, 잠정 — 실측 대체 예정) = 128MB. 실측 표본: composite 정본 — 방안당 12케이스(오라클 채점 10 + 대형 2) 및 4-10축 스윕.</a:t>
+              <a:t>한도 유도: 플래그십 단말 전형의 앱 힙 상한 256MB × 75%(GC 성능 여유) − 64MB(협상 외 앱 기본 점유, 잠정 — 실측 대체 예정) = 128MB. 로그 사다리 개정 근거: 선형 15%p 등분은 실측에서 4-16축 전부 ★5 → 20축 절벽으로 포화 (24 §2.8). 실측 표본: composite 정본 FIN 500건 (63번 문서).</a:t>
             </a:r>
           </a:p>
         </p:txBody>
@@ -3991,7 +3991,7 @@
                 </a:solidFill>
                 <a:latin typeface="맑은 고딕"/>
               </a:rPr>
-              <a:t>2026-08-13  ·  정본: 24-QA-측정-핸드북 (본 자료는 요약)</a:t>
+              <a:t>2026-08-14 갱신  ·  정본: 24-QA-측정-핸드북 (본 자료는 요약)</a:t>
             </a:r>
           </a:p>
         </p:txBody>
@@ -4171,7 +4171,7 @@
                 </a:solidFill>
                 <a:latin typeface="맑은 고딕"/>
               </a:rPr>
-              <a:t>  (하한 미달이 곧 요구 미달인 QA는 최하 칸을 '결함'으로 표기)</a:t>
+              <a:t>  (한계 초과가 곧 성립 불가인 QA는 최하 칸을 '결함'으로 표기)</a:t>
             </a:r>
           </a:p>
           <a:p>
@@ -4257,7 +4257,7 @@
         </p:nvGraphicFramePr>
         <p:xfrm>
           <a:off x="411480" y="3657600"/>
-          <a:ext cx="11384280" cy="2103120"/>
+          <a:ext cx="11384280" cy="2651760"/>
         </p:xfrm>
         <a:graphic>
           <a:graphicData uri="http://schemas.openxmlformats.org/drawingml/2006/table">
@@ -4270,7 +4270,7 @@
                 <a:gridCol w="3108960"/>
                 <a:gridCol w="6263640"/>
               </a:tblGrid>
-              <a:tr h="701040">
+              <a:tr h="662940">
                 <a:tc>
                   <a:txBody>
                     <a:bodyPr/>
@@ -4338,7 +4338,7 @@
                   </a:tcPr>
                 </a:tc>
               </a:tr>
-              <a:tr h="701040">
+              <a:tr h="662940">
                 <a:tc>
                   <a:txBody>
                     <a:bodyPr/>
@@ -4439,7 +4439,7 @@
                   </a:tcPr>
                 </a:tc>
               </a:tr>
-              <a:tr h="701040">
+              <a:tr h="662940">
                 <a:tc>
                   <a:txBody>
                     <a:bodyPr/>
@@ -4485,7 +4485,7 @@
                           </a:solidFill>
                           <a:latin typeface="맑은 고딕"/>
                         </a:rPr>
-                        <a:t>자원-메모리(RU)</a:t>
+                        <a:t>기능 정확성(FC) · 자원(RU)</a:t>
                       </a:r>
                     </a:p>
                     <a:p>
@@ -4496,7 +4496,7 @@
                           </a:solidFill>
                           <a:latin typeface="맑은 고딕"/>
                         </a:rPr>
-                        <a:t>· 확장성-의제(SC)</a:t>
+                        <a:t>· 시간(TB)</a:t>
                       </a:r>
                     </a:p>
                   </a:txBody>
@@ -4518,7 +4518,7 @@
                           </a:solidFill>
                           <a:latin typeface="맑은 고딕"/>
                         </a:rPr>
-                        <a:t>seq2 (의제 순차 협상 — 개선판)</a:t>
+                        <a:t>방안 1 seq2 (의제를 한 축씩 순차 확정 — 경로 의존)</a:t>
                       </a:r>
                     </a:p>
                     <a:p>
@@ -4529,7 +4529,86 @@
                           </a:solidFill>
                           <a:latin typeface="맑은 고딕"/>
                         </a:rPr>
-                        <a:t>vs pool (후보 풀 일괄 협상)</a:t>
+                        <a:t>vs 방안 2 pool (축별 상위값 조합 풀로 한 판에 협상 — 지수 성장)</a:t>
+                      </a:r>
+                    </a:p>
+                  </a:txBody>
+                  <a:tcPr anchor="ctr">
+                    <a:solidFill>
+                      <a:srgbClr val="FFFFFF"/>
+                    </a:solidFill>
+                  </a:tcPr>
+                </a:tc>
+              </a:tr>
+              <a:tr h="662940">
+                <a:tc>
+                  <a:txBody>
+                    <a:bodyPr/>
+                    <a:lstStyle/>
+                    <a:p>
+                      <a:r>
+                        <a:rPr sz="1200" b="1">
+                          <a:solidFill>
+                            <a:srgbClr val="262626"/>
+                          </a:solidFill>
+                          <a:latin typeface="맑은 고딕"/>
+                        </a:rPr>
+                        <a:t>확장성-의제(SC)</a:t>
+                      </a:r>
+                    </a:p>
+                  </a:txBody>
+                  <a:tcPr anchor="ctr">
+                    <a:solidFill>
+                      <a:srgbClr val="FFFFFF"/>
+                    </a:solidFill>
+                  </a:tcPr>
+                </a:tc>
+                <a:tc>
+                  <a:txBody>
+                    <a:bodyPr/>
+                    <a:lstStyle/>
+                    <a:p>
+                      <a:r>
+                        <a:rPr sz="1200" b="0">
+                          <a:solidFill>
+                            <a:srgbClr val="262626"/>
+                          </a:solidFill>
+                          <a:latin typeface="맑은 고딕"/>
+                        </a:rPr>
+                        <a:t>composite 축 수 스윕으로</a:t>
+                      </a:r>
+                    </a:p>
+                    <a:p>
+                      <a:r>
+                        <a:rPr sz="1200" b="0">
+                          <a:solidFill>
+                            <a:srgbClr val="262626"/>
+                          </a:solidFill>
+                          <a:latin typeface="맑은 고딕"/>
+                        </a:rPr>
+                        <a:t>별도 판정</a:t>
+                      </a:r>
+                    </a:p>
+                  </a:txBody>
+                  <a:tcPr anchor="ctr">
+                    <a:solidFill>
+                      <a:srgbClr val="FFFFFF"/>
+                    </a:solidFill>
+                  </a:tcPr>
+                </a:tc>
+                <a:tc>
+                  <a:txBody>
+                    <a:bodyPr/>
+                    <a:lstStyle/>
+                    <a:p>
+                      <a:r>
+                        <a:rPr sz="1200" b="0">
+                          <a:solidFill>
+                            <a:srgbClr val="262626"/>
+                          </a:solidFill>
+                          <a:latin typeface="맑은 고딕"/>
+                        </a:rPr>
+                        <a:t>위 composite 2방안</a:t>
                       </a:r>
                     </a:p>
                   </a:txBody>
@@ -5339,79 +5418,104 @@
           <a:p>
             <a:pPr>
               <a:spcAft>
+                <a:spcPts val="400"/>
+              </a:spcAft>
+            </a:pPr>
+            <a:r>
+              <a:rPr sz="1350" b="1">
+                <a:solidFill>
+                  <a:srgbClr val="2E74B5"/>
+                </a:solidFill>
+                <a:latin typeface="맑은 고딕"/>
+              </a:rPr>
+              <a:t>다자: 방안 2  0.959 ★5</a:t>
+            </a:r>
+            <a:r>
+              <a:rPr sz="1350" b="1">
+                <a:solidFill>
+                  <a:srgbClr val="262626"/>
+                </a:solidFill>
+                <a:latin typeface="맑은 고딕"/>
+              </a:rPr>
+              <a:t>  vs  1-A  0.866 ★3</a:t>
+            </a:r>
+          </a:p>
+          <a:p>
+            <a:pPr>
+              <a:spcAft>
+                <a:spcPts val="300"/>
+              </a:spcAft>
+            </a:pPr>
+            <a:r>
+              <a:rPr sz="1150" b="0">
+                <a:solidFill>
+                  <a:srgbClr val="262626"/>
+                </a:solidFill>
+                <a:latin typeface="맑은 고딕"/>
+              </a:rPr>
+              <a:t>무작위도 평균 0.86인 판 — 1-A는 무작위와 사실상 동급 (s 0.04 vs 0.71)</a:t>
+            </a:r>
+          </a:p>
+          <a:p>
+            <a:pPr>
+              <a:spcAft>
+                <a:spcPts val="400"/>
+              </a:spcAft>
+            </a:pPr>
+            <a:r>
+              <a:rPr sz="1150" b="0">
+                <a:solidFill>
+                  <a:srgbClr val="262626"/>
+                </a:solidFill>
+                <a:latin typeface="맑은 고딕"/>
+              </a:rPr>
+              <a:t>결렬이 정답인 96개 판: 양 방안 96/96 정확히 결렬</a:t>
+            </a:r>
+          </a:p>
+          <a:p>
+            <a:pPr>
+              <a:spcAft>
+                <a:spcPts val="300"/>
+              </a:spcAft>
+            </a:pPr>
+            <a:r>
+              <a:rPr sz="1350" b="1">
+                <a:solidFill>
+                  <a:srgbClr val="2E74B5"/>
+                </a:solidFill>
+                <a:latin typeface="맑은 고딕"/>
+              </a:rPr>
+              <a:t>복합: pool  0.941 ★4</a:t>
+            </a:r>
+            <a:r>
+              <a:rPr sz="1350" b="1">
+                <a:solidFill>
+                  <a:srgbClr val="262626"/>
+                </a:solidFill>
+                <a:latin typeface="맑은 고딕"/>
+              </a:rPr>
+              <a:t>  vs  seq2  0.880 ★3</a:t>
+            </a:r>
+          </a:p>
+          <a:p>
+            <a:pPr>
+              <a:spcAft>
                 <a:spcPts val="500"/>
               </a:spcAft>
             </a:pPr>
             <a:r>
-              <a:rPr sz="1400" b="1">
-                <a:solidFill>
-                  <a:srgbClr val="2E74B5"/>
-                </a:solidFill>
-                <a:latin typeface="맑은 고딕"/>
-              </a:rPr>
-              <a:t>방안 2  0.959 ★5</a:t>
-            </a:r>
-            <a:r>
-              <a:rPr sz="1400" b="1">
+              <a:rPr sz="1150" b="0">
                 <a:solidFill>
                   <a:srgbClr val="262626"/>
                 </a:solidFill>
                 <a:latin typeface="맑은 고딕"/>
               </a:rPr>
-              <a:t>  vs  방안 1-A  0.866 ★3</a:t>
+              <a:t>격차의 출처는 경로 함정 판 (0.955 vs 0.569)</a:t>
             </a:r>
           </a:p>
           <a:p>
             <a:pPr>
               <a:spcAft>
-                <a:spcPts val="300"/>
-              </a:spcAft>
-            </a:pPr>
-            <a:r>
-              <a:rPr sz="1200" b="0">
-                <a:solidFill>
-                  <a:srgbClr val="262626"/>
-                </a:solidFill>
-                <a:latin typeface="맑은 고딕"/>
-              </a:rPr>
-              <a:t>단, 무작위로 골라도 평균 0.86인 판 — 1-A의 실체는 무작위와 사실상 동급</a:t>
-            </a:r>
-          </a:p>
-          <a:p>
-            <a:pPr>
-              <a:spcAft>
-                <a:spcPts val="500"/>
-              </a:spcAft>
-            </a:pPr>
-            <a:r>
-              <a:rPr sz="1150" b="0">
-                <a:solidFill>
-                  <a:srgbClr val="595959"/>
-                </a:solidFill>
-                <a:latin typeface="맑은 고딕"/>
-              </a:rPr>
-              <a:t>(개선율 s: 1-A 0.04 vs 방안 2 0.71)</a:t>
-            </a:r>
-          </a:p>
-          <a:p>
-            <a:pPr>
-              <a:spcAft>
-                <a:spcPts val="600"/>
-              </a:spcAft>
-            </a:pPr>
-            <a:r>
-              <a:rPr sz="1200" b="0">
-                <a:solidFill>
-                  <a:srgbClr val="262626"/>
-                </a:solidFill>
-                <a:latin typeface="맑은 고딕"/>
-              </a:rPr>
-              <a:t>결렬이 정답인 96개 판: 양 방안 96/96 정확히 결렬</a:t>
-            </a:r>
-          </a:p>
-          <a:p>
-            <a:pPr>
-              <a:spcAft>
                 <a:spcPts val="0"/>
               </a:spcAft>
             </a:pPr>
@@ -5422,7 +5526,7 @@
                 </a:solidFill>
                 <a:latin typeface="맑은 고딕"/>
               </a:rPr>
-              <a:t>시사점 — 합의 품질은 방안 2의 압승 (케이스 승패 273:15)</a:t>
+              <a:t>시사점 — 두 DP 모두 합의 품질은 방안 2 계열 우세</a:t>
             </a:r>
           </a:p>
         </p:txBody>
@@ -5572,7 +5676,7 @@
                 </a:solidFill>
                 <a:latin typeface="맑은 고딕"/>
               </a:rPr>
-              <a:t>협상 중 가장 무거운 단말의 순간 메모리 피크가, 협상에 허용된 몫(128MB)의 몇 %인가 — 사용률 r</a:t>
+              <a:t>협상 중 가장 무거운 단말의 순간 메모리 피크가, 협상 몫(128MB)의 몇 %인가 — 사용률 r의 P95로 판정</a:t>
             </a:r>
           </a:p>
         </p:txBody>
@@ -5756,6 +5860,22 @@
                 <a:latin typeface="맑은 고딕"/>
               </a:rPr>
               <a:t>N명의 합이 아니라 최대 부하 단말 1대 기준 — 죽는 것은 합이 아니라 한 대</a:t>
+            </a:r>
+          </a:p>
+          <a:p>
+            <a:pPr>
+              <a:spcAft>
+                <a:spcPts val="300"/>
+              </a:spcAft>
+            </a:pPr>
+            <a:r>
+              <a:rPr sz="1250" b="1">
+                <a:solidFill>
+                  <a:srgbClr val="262626"/>
+                </a:solidFill>
+                <a:latin typeface="맑은 고딕"/>
+              </a:rPr>
+              <a:t>판정 = P95 (OOM은 꼬리 사건) · 지수 성장 도메인이라 별점은 로그 계단 — 1칸 = 10배 여유</a:t>
             </a:r>
           </a:p>
           <a:p>
@@ -5850,13 +5970,12 @@
                 <a:tableStyleId>{5C22544A-7EE6-4342-B048-85BDC9FD1C3A}</a:tableStyleId>
               </a:tblPr>
               <a:tblGrid>
-                <a:gridCol w="803365"/>
-                <a:gridCol w="803365"/>
-                <a:gridCol w="803365"/>
-                <a:gridCol w="803365"/>
-                <a:gridCol w="803365"/>
-                <a:gridCol w="803365"/>
-                <a:gridCol w="803370"/>
+                <a:gridCol w="937260"/>
+                <a:gridCol w="937260"/>
+                <a:gridCol w="937260"/>
+                <a:gridCol w="937260"/>
+                <a:gridCol w="937260"/>
+                <a:gridCol w="937260"/>
               </a:tblGrid>
               <a:tr h="342900">
                 <a:tc>
@@ -5987,29 +6106,6 @@
                           </a:solidFill>
                           <a:latin typeface="맑은 고딕"/>
                         </a:rPr>
-                        <a:t>★0</a:t>
-                      </a:r>
-                    </a:p>
-                  </a:txBody>
-                  <a:tcPr marL="25400" marR="25400" marT="12700" marB="12700" anchor="ctr">
-                    <a:solidFill>
-                      <a:srgbClr val="1F3864"/>
-                    </a:solidFill>
-                  </a:tcPr>
-                </a:tc>
-                <a:tc>
-                  <a:txBody>
-                    <a:bodyPr/>
-                    <a:lstStyle/>
-                    <a:p>
-                      <a:pPr algn="ctr"/>
-                      <a:r>
-                        <a:rPr sz="1100" b="1">
-                          <a:solidFill>
-                            <a:srgbClr val="FFFFFF"/>
-                          </a:solidFill>
-                          <a:latin typeface="맑은 고딕"/>
-                        </a:rPr>
                         <a:t>결함</a:t>
                       </a:r>
                     </a:p>
@@ -6035,7 +6131,7 @@
                           </a:solidFill>
                           <a:latin typeface="맑은 고딕"/>
                         </a:rPr>
-                        <a:t>≤15%</a:t>
+                        <a:t>≤0.01%</a:t>
                       </a:r>
                     </a:p>
                   </a:txBody>
@@ -6058,7 +6154,7 @@
                           </a:solidFill>
                           <a:latin typeface="맑은 고딕"/>
                         </a:rPr>
-                        <a:t>≤30%</a:t>
+                        <a:t>≤0.1%</a:t>
                       </a:r>
                     </a:p>
                   </a:txBody>
@@ -6081,7 +6177,7 @@
                           </a:solidFill>
                           <a:latin typeface="맑은 고딕"/>
                         </a:rPr>
-                        <a:t>≤45%</a:t>
+                        <a:t>≤1%</a:t>
                       </a:r>
                     </a:p>
                   </a:txBody>
@@ -6104,7 +6200,7 @@
                           </a:solidFill>
                           <a:latin typeface="맑은 고딕"/>
                         </a:rPr>
-                        <a:t>≤60%</a:t>
+                        <a:t>≤10%</a:t>
                       </a:r>
                     </a:p>
                   </a:txBody>
@@ -6127,30 +6223,7 @@
                           </a:solidFill>
                           <a:latin typeface="맑은 고딕"/>
                         </a:rPr>
-                        <a:t>≤75%</a:t>
-                      </a:r>
-                    </a:p>
-                  </a:txBody>
-                  <a:tcPr marL="25400" marR="25400" marT="12700" marB="12700" anchor="ctr">
-                    <a:solidFill>
-                      <a:srgbClr val="FFFFFF"/>
-                    </a:solidFill>
-                  </a:tcPr>
-                </a:tc>
-                <a:tc>
-                  <a:txBody>
-                    <a:bodyPr/>
-                    <a:lstStyle/>
-                    <a:p>
-                      <a:pPr algn="ctr"/>
-                      <a:r>
-                        <a:rPr sz="1100" b="0">
-                          <a:solidFill>
-                            <a:srgbClr val="262626"/>
-                          </a:solidFill>
-                          <a:latin typeface="맑은 고딕"/>
-                        </a:rPr>
-                        <a:t>75-100%</a:t>
+                        <a:t>≤100%</a:t>
                       </a:r>
                     </a:p>
                   </a:txBody>
@@ -6238,7 +6311,7 @@
                 </a:solidFill>
                 <a:latin typeface="맑은 고딕"/>
               </a:rPr>
-              <a:t>한도의 75%까지 15%p 선형 등분 — 위 25%는 동시 부하·측정 오차용 안전 여유</a:t>
+              <a:t>로그(데케이드) 사다리 — 선형 등분은 지수 도메인에서 포화 (24 §2.8 개정 2026-08-13)</a:t>
             </a:r>
           </a:p>
         </p:txBody>
@@ -6301,63 +6374,79 @@
           <a:p>
             <a:pPr>
               <a:spcAft>
+                <a:spcPts val="400"/>
+              </a:spcAft>
+            </a:pPr>
+            <a:r>
+              <a:rPr sz="1400" b="1">
+                <a:solidFill>
+                  <a:srgbClr val="2E74B5"/>
+                </a:solidFill>
+                <a:latin typeface="맑은 고딕"/>
+              </a:rPr>
+              <a:t>seq2  P95 0.30% ★3</a:t>
+            </a:r>
+            <a:r>
+              <a:rPr sz="1400" b="1">
+                <a:solidFill>
+                  <a:srgbClr val="262626"/>
+                </a:solidFill>
+                <a:latin typeface="맑은 고딕"/>
+              </a:rPr>
+              <a:t>  vs  pool  48.2% ★1</a:t>
+            </a:r>
+          </a:p>
+          <a:p>
+            <a:pPr>
+              <a:spcAft>
+                <a:spcPts val="300"/>
+              </a:spcAft>
+            </a:pPr>
+            <a:r>
+              <a:rPr sz="1200" b="0">
+                <a:solidFill>
+                  <a:srgbClr val="C0392B"/>
+                </a:solidFill>
+                <a:latin typeface="맑은 고딕"/>
+              </a:rPr>
+              <a:t>한도 초과: seq2 0건 vs pool 11건 (의제 18축 이상, 최악 4.7GB)</a:t>
+            </a:r>
+          </a:p>
+          <a:p>
+            <a:pPr>
+              <a:spcAft>
+                <a:spcPts val="300"/>
+              </a:spcAft>
+            </a:pPr>
+            <a:r>
+              <a:rPr sz="1200" b="0">
+                <a:solidFill>
+                  <a:srgbClr val="262626"/>
+                </a:solidFill>
+                <a:latin typeface="맑은 고딕"/>
+              </a:rPr>
+              <a:t>seq2는 전 구간 0.4MB 이하로 평평 · pool은 12축 0.5MB → 20축 110MB로 지수 성장</a:t>
+            </a:r>
+          </a:p>
+          <a:p>
+            <a:pPr>
+              <a:spcAft>
                 <a:spcPts val="500"/>
               </a:spcAft>
             </a:pPr>
             <a:r>
-              <a:rPr sz="1400" b="1">
-                <a:solidFill>
-                  <a:srgbClr val="2E74B5"/>
-                </a:solidFill>
-                <a:latin typeface="맑은 고딕"/>
-              </a:rPr>
-              <a:t>두 방안 모두  중앙 r = 0.9% ★5</a:t>
-            </a:r>
-            <a:r>
-              <a:rPr sz="1400" b="0">
-                <a:solidFill>
-                  <a:srgbClr val="262626"/>
-                </a:solidFill>
-                <a:latin typeface="맑은 고딕"/>
-              </a:rPr>
-              <a:t>  ·  한도 초과 0건</a:t>
+              <a:rPr sz="1150" b="0">
+                <a:solidFill>
+                  <a:srgbClr val="595959"/>
+                </a:solidFill>
+                <a:latin typeface="맑은 고딕"/>
+              </a:rPr>
+              <a:t>(소규모에선 pool이 더 가볍고, 역전은 11축부터)</a:t>
             </a:r>
           </a:p>
           <a:p>
             <a:pPr>
               <a:spcAft>
-                <a:spcPts val="300"/>
-              </a:spcAft>
-            </a:pPr>
-            <a:r>
-              <a:rPr sz="1200" b="0">
-                <a:solidFill>
-                  <a:srgbClr val="262626"/>
-                </a:solidFill>
-                <a:latin typeface="맑은 고딕"/>
-              </a:rPr>
-              <a:t>최악 케이스(6축·10만 조합)도 r = 42.7% ★3</a:t>
-            </a:r>
-          </a:p>
-          <a:p>
-            <a:pPr>
-              <a:spcAft>
-                <a:spcPts val="600"/>
-              </a:spcAft>
-            </a:pPr>
-            <a:r>
-              <a:rPr sz="1200" b="1">
-                <a:solidFill>
-                  <a:srgbClr val="262626"/>
-                </a:solidFill>
-                <a:latin typeface="맑은 고딕"/>
-              </a:rPr>
-              <a:t>977만 조합의 초대형 판에서도 r &lt; 1% — 조합 폭발이 메모리 폭발로 이어지지 않음을 실증</a:t>
-            </a:r>
-          </a:p>
-          <a:p>
-            <a:pPr>
-              <a:spcAft>
                 <a:spcPts val="0"/>
               </a:spcAft>
             </a:pPr>
@@ -6368,7 +6457,7 @@
                 </a:solidFill>
                 <a:latin typeface="맑은 고딕"/>
               </a:rPr>
-              <a:t>시사점 — 두 방안 모두 여유, 변별축 아님</a:t>
+              <a:t>시사점 — 메모리는 seq2의 구조적 우위, pool은 의제 16축 이하 조건부</a:t>
             </a:r>
           </a:p>
         </p:txBody>
@@ -8099,81 +8188,106 @@
           <a:p>
             <a:pPr>
               <a:spcAft>
+                <a:spcPts val="300"/>
+              </a:spcAft>
+            </a:pPr>
+            <a:r>
+              <a:rPr sz="1300" b="1">
+                <a:solidFill>
+                  <a:srgbClr val="2E74B5"/>
+                </a:solidFill>
+                <a:latin typeface="맑은 고딕"/>
+              </a:rPr>
+              <a:t>다자: 50인 협상도 약 3초 — naive는 61.5초</a:t>
+            </a:r>
+          </a:p>
+          <a:p>
+            <a:pPr>
+              <a:spcAft>
+                <a:spcPts val="300"/>
+              </a:spcAft>
+            </a:pPr>
+            <a:r>
+              <a:rPr sz="1150" b="0">
+                <a:solidFill>
+                  <a:srgbClr val="262626"/>
+                </a:solidFill>
+                <a:latin typeface="맑은 고딕"/>
+              </a:rPr>
+              <a:t>판정(P95): 1-A 0.556 ★3 vs 방안 2 0.689 ★2 (전형 중앙값은 0.15 vs 0.17로 동급)</a:t>
+            </a:r>
+          </a:p>
+          <a:p>
+            <a:pPr>
+              <a:spcAft>
+                <a:spcPts val="400"/>
+              </a:spcAft>
+            </a:pPr>
+            <a:r>
+              <a:rPr sz="1150" b="0">
+                <a:solidFill>
+                  <a:srgbClr val="C0392B"/>
+                </a:solidFill>
+                <a:latin typeface="맑은 고딕"/>
+              </a:rPr>
+              <a:t>방안 2는 3인 최악 구간 naive 근접(0.954) + 즉시 결함 1건</a:t>
+            </a:r>
+          </a:p>
+          <a:p>
+            <a:pPr>
+              <a:spcAft>
+                <a:spcPts val="300"/>
+              </a:spcAft>
+            </a:pPr>
+            <a:r>
+              <a:rPr sz="1300" b="1">
+                <a:solidFill>
+                  <a:srgbClr val="2E74B5"/>
+                </a:solidFill>
+                <a:latin typeface="맑은 고딕"/>
+              </a:rPr>
+              <a:t>복합: pool P95 0.633 ★2 (T 중앙 2.0s)</a:t>
+            </a:r>
+            <a:r>
+              <a:rPr sz="1300" b="1">
+                <a:solidFill>
+                  <a:srgbClr val="262626"/>
+                </a:solidFill>
+                <a:latin typeface="맑은 고딕"/>
+              </a:rPr>
+              <a:t>  vs  seq2 4.24 ★0</a:t>
+            </a:r>
+          </a:p>
+          <a:p>
+            <a:pPr>
+              <a:spcAft>
                 <a:spcPts val="500"/>
               </a:spcAft>
             </a:pPr>
             <a:r>
-              <a:rPr sz="1350" b="1">
-                <a:solidFill>
-                  <a:srgbClr val="2E74B5"/>
-                </a:solidFill>
-                <a:latin typeface="맑은 고딕"/>
-              </a:rPr>
-              <a:t>50인 협상도 약 3초 (1-A 2.6s · 방안 2 3.0s) — naive는 61.5초</a:t>
+              <a:rPr sz="1150" b="0">
+                <a:solidFill>
+                  <a:srgbClr val="C0392B"/>
+                </a:solidFill>
+                <a:latin typeface="맑은 고딕"/>
+              </a:rPr>
+              <a:t>seq2는 결함 152건 — 백트랙 반복으로 naive보다 느린 꼬리 (T 중앙 9.0s)</a:t>
             </a:r>
           </a:p>
           <a:p>
             <a:pPr>
               <a:spcAft>
-                <a:spcPts val="300"/>
+                <a:spcPts val="0"/>
               </a:spcAft>
             </a:pPr>
             <a:r>
               <a:rPr sz="1300" b="1">
                 <a:solidFill>
-                  <a:srgbClr val="262626"/>
-                </a:solidFill>
-                <a:latin typeface="맑은 고딕"/>
-              </a:rPr>
-              <a:t>판정(P95): 1-A 0.556 ★3 vs 방안 2 0.689 ★2</a:t>
-            </a:r>
-          </a:p>
-          <a:p>
-            <a:pPr>
-              <a:spcAft>
-                <a:spcPts val="300"/>
-              </a:spcAft>
-            </a:pPr>
-            <a:r>
-              <a:rPr sz="1200" b="0">
-                <a:solidFill>
-                  <a:srgbClr val="262626"/>
-                </a:solidFill>
-                <a:latin typeface="맑은 고딕"/>
-              </a:rPr>
-              <a:t>전형(중앙값)은 0.15 vs 0.17로 동급 — 갈리는 것은 느린 꼬리</a:t>
-            </a:r>
-          </a:p>
-          <a:p>
-            <a:pPr>
-              <a:spcAft>
-                <a:spcPts val="500"/>
-              </a:spcAft>
-            </a:pPr>
-            <a:r>
-              <a:rPr sz="1150" b="0">
-                <a:solidFill>
-                  <a:srgbClr val="C0392B"/>
-                </a:solidFill>
-                <a:latin typeface="맑은 고딕"/>
-              </a:rPr>
-              <a:t>방안 2: 3인 소규모 최악 구간에서 naive 근접(P95 0.954) + 즉시 결함 1건 (ρ&gt;1 — naive보다 느림)</a:t>
-            </a:r>
-          </a:p>
-          <a:p>
-            <a:pPr>
-              <a:spcAft>
-                <a:spcPts val="0"/>
-              </a:spcAft>
-            </a:pPr>
-            <a:r>
-              <a:rPr sz="1300" b="1">
-                <a:solidFill>
                   <a:srgbClr val="1F3864"/>
                 </a:solidFill>
                 <a:latin typeface="맑은 고딕"/>
               </a:rPr>
-              <a:t>시사점 — 응답성 보장은 1-A가 한 등급 위</a:t>
+              <a:t>시사점 — 다자 판은 1-A, 복합 판은 pool이 응답성 우위</a:t>
             </a:r>
           </a:p>
         </p:txBody>
@@ -9021,65 +9135,74 @@
           <a:p>
             <a:pPr>
               <a:spcAft>
+                <a:spcPts val="400"/>
+              </a:spcAft>
+            </a:pPr>
+            <a:r>
+              <a:rPr sz="1300" b="1">
+                <a:solidFill>
+                  <a:srgbClr val="2E74B5"/>
+                </a:solidFill>
+                <a:latin typeface="맑은 고딕"/>
+              </a:rPr>
+              <a:t>구 스윕(4-10축): 두 방안 모두 10축 통과 ★4</a:t>
+            </a:r>
+            <a:r>
+              <a:rPr sz="1300" b="0">
+                <a:solidFill>
+                  <a:srgbClr val="595959"/>
+                </a:solidFill>
+                <a:latin typeface="맑은 고딕"/>
+              </a:rPr>
+              <a:t> (관측 상한, censored)</a:t>
+            </a:r>
+          </a:p>
+          <a:p>
+            <a:pPr>
+              <a:spcAft>
+                <a:spcPts val="200"/>
+              </a:spcAft>
+            </a:pPr>
+            <a:r>
+              <a:rPr sz="1200" b="0">
+                <a:solidFill>
+                  <a:srgbClr val="262626"/>
+                </a:solidFill>
+                <a:latin typeface="맑은 고딕"/>
+              </a:rPr>
+              <a:t>FIN 500건 참고 관측 — seq2는 20축에서도 한도 내(≤0.4MB) 완결,</a:t>
+            </a:r>
+          </a:p>
+          <a:p>
+            <a:pPr>
+              <a:spcAft>
                 <a:spcPts val="500"/>
               </a:spcAft>
             </a:pPr>
             <a:r>
-              <a:rPr sz="1400" b="1">
-                <a:solidFill>
-                  <a:srgbClr val="2E74B5"/>
-                </a:solidFill>
-                <a:latin typeface="맑은 고딕"/>
-              </a:rPr>
-              <a:t>두 방안 모두  10축 통과 ★4</a:t>
+              <a:rPr sz="1200" b="0">
+                <a:solidFill>
+                  <a:srgbClr val="262626"/>
+                </a:solidFill>
+                <a:latin typeface="맑은 고딕"/>
+              </a:rPr>
+              <a:t>pool은 18축 이상 한도 초과 → 실질 한계 약 16축</a:t>
             </a:r>
           </a:p>
           <a:p>
             <a:pPr>
               <a:spcAft>
-                <a:spcPts val="300"/>
-              </a:spcAft>
-            </a:pPr>
-            <a:r>
-              <a:rPr sz="1200" b="0">
-                <a:solidFill>
-                  <a:srgbClr val="262626"/>
-                </a:solidFill>
-                <a:latin typeface="맑은 고딕"/>
-              </a:rPr>
-              <a:t>단, 준비된 스윕의 상한까지 전부 통과 (관측 상한 도달, censored)</a:t>
-            </a:r>
-          </a:p>
-          <a:p>
-            <a:pPr>
-              <a:spcAft>
-                <a:spcPts val="600"/>
-              </a:spcAft>
-            </a:pPr>
-            <a:r>
-              <a:rPr sz="1200" b="0">
-                <a:solidFill>
-                  <a:srgbClr val="262626"/>
-                </a:solidFill>
-                <a:latin typeface="맑은 고딕"/>
-              </a:rPr>
-              <a:t>— 실제 한계는 그 이상일 수 있다</a:t>
-            </a:r>
-          </a:p>
-          <a:p>
-            <a:pPr>
-              <a:spcAft>
                 <a:spcPts val="0"/>
               </a:spcAft>
             </a:pPr>
             <a:r>
-              <a:rPr sz="1250" b="1">
+              <a:rPr sz="1200" b="1">
                 <a:solidFill>
                   <a:srgbClr val="1F3864"/>
                 </a:solidFill>
                 <a:latin typeface="맑은 고딕"/>
               </a:rPr>
-              <a:t>시사점 — 두 방안 모두 실사용 상한(12축) 근접 · 12축+ 스윕 확장으로 만점 여부 확정이 후속 과제</a:t>
+              <a:t>시사점 — seq2는 만점권, pool은 실사용 상한(12축)은 넘기나 그 위가 막힘 · 정식 SC 스윕 재판정 예정</a:t>
             </a:r>
           </a:p>
         </p:txBody>
@@ -9599,7 +9722,7 @@
         </p:nvGraphicFramePr>
         <p:xfrm>
           <a:off x="6400800" y="1691640"/>
-          <a:ext cx="5394960" cy="1645919"/>
+          <a:ext cx="5394960" cy="2743200"/>
         </p:xfrm>
         <a:graphic>
           <a:graphicData uri="http://schemas.openxmlformats.org/drawingml/2006/table">
@@ -9612,7 +9735,7 @@
                 <a:gridCol w="1371600"/>
                 <a:gridCol w="1371600"/>
               </a:tblGrid>
-              <a:tr h="548639">
+              <a:tr h="548640">
                 <a:tc>
                   <a:txBody>
                     <a:bodyPr/>
@@ -9683,7 +9806,7 @@
                   </a:tcPr>
                 </a:tc>
               </a:tr>
-              <a:tr h="548639">
+              <a:tr h="548640">
                 <a:tc>
                   <a:txBody>
                     <a:bodyPr/>
@@ -9697,7 +9820,30 @@
                           </a:solidFill>
                           <a:latin typeface="맑은 고딕"/>
                         </a:rPr>
-                        <a:t>2. 자원-메모리</a:t>
+                        <a:t>1. 기능 정확성</a:t>
+                      </a:r>
+                    </a:p>
+                  </a:txBody>
+                  <a:tcPr anchor="ctr">
+                    <a:solidFill>
+                      <a:srgbClr val="FFFFFF"/>
+                    </a:solidFill>
+                  </a:tcPr>
+                </a:tc>
+                <a:tc>
+                  <a:txBody>
+                    <a:bodyPr/>
+                    <a:lstStyle/>
+                    <a:p>
+                      <a:pPr algn="ctr"/>
+                      <a:r>
+                        <a:rPr sz="1300" b="0">
+                          <a:solidFill>
+                            <a:srgbClr val="262626"/>
+                          </a:solidFill>
+                          <a:latin typeface="맑은 고딕"/>
+                        </a:rPr>
+                        <a:t>★3</a:t>
                       </a:r>
                     </a:p>
                   </a:txBody>
@@ -9720,7 +9866,55 @@
                           </a:solidFill>
                           <a:latin typeface="맑은 고딕"/>
                         </a:rPr>
-                        <a:t>★5</a:t>
+                        <a:t>★4</a:t>
+                      </a:r>
+                    </a:p>
+                  </a:txBody>
+                  <a:tcPr anchor="ctr">
+                    <a:solidFill>
+                      <a:srgbClr val="DEEBF7"/>
+                    </a:solidFill>
+                  </a:tcPr>
+                </a:tc>
+              </a:tr>
+              <a:tr h="548640">
+                <a:tc>
+                  <a:txBody>
+                    <a:bodyPr/>
+                    <a:lstStyle/>
+                    <a:p>
+                      <a:pPr algn="l"/>
+                      <a:r>
+                        <a:rPr sz="1300" b="1">
+                          <a:solidFill>
+                            <a:srgbClr val="262626"/>
+                          </a:solidFill>
+                          <a:latin typeface="맑은 고딕"/>
+                        </a:rPr>
+                        <a:t>2. 자원 (P95)</a:t>
+                      </a:r>
+                    </a:p>
+                  </a:txBody>
+                  <a:tcPr anchor="ctr">
+                    <a:solidFill>
+                      <a:srgbClr val="FFFFFF"/>
+                    </a:solidFill>
+                  </a:tcPr>
+                </a:tc>
+                <a:tc>
+                  <a:txBody>
+                    <a:bodyPr/>
+                    <a:lstStyle/>
+                    <a:p>
+                      <a:pPr algn="ctr"/>
+                      <a:r>
+                        <a:rPr sz="1300" b="1">
+                          <a:solidFill>
+                            <a:srgbClr val="262626"/>
+                          </a:solidFill>
+                          <a:latin typeface="맑은 고딕"/>
+                        </a:rPr>
+                        <a:t>★3</a:t>
                       </a:r>
                     </a:p>
                   </a:txBody>
@@ -9737,24 +9931,24 @@
                     <a:p>
                       <a:pPr algn="ctr"/>
                       <a:r>
-                        <a:rPr sz="1300" b="1">
+                        <a:rPr sz="1300" b="0">
                           <a:solidFill>
                             <a:srgbClr val="262626"/>
                           </a:solidFill>
                           <a:latin typeface="맑은 고딕"/>
                         </a:rPr>
-                        <a:t>★5</a:t>
+                        <a:t>★1 (결함 11)</a:t>
                       </a:r>
                     </a:p>
                   </a:txBody>
                   <a:tcPr anchor="ctr">
                     <a:solidFill>
-                      <a:srgbClr val="DEEBF7"/>
+                      <a:srgbClr val="FFFFFF"/>
                     </a:solidFill>
                   </a:tcPr>
                 </a:tc>
               </a:tr>
-              <a:tr h="548641">
+              <a:tr h="548640">
                 <a:tc>
                   <a:txBody>
                     <a:bodyPr/>
@@ -9768,7 +9962,78 @@
                           </a:solidFill>
                           <a:latin typeface="맑은 고딕"/>
                         </a:rPr>
-                        <a:t>5. 확장성-의제</a:t>
+                        <a:t>4. 시간 (P95)</a:t>
+                      </a:r>
+                    </a:p>
+                  </a:txBody>
+                  <a:tcPr anchor="ctr">
+                    <a:solidFill>
+                      <a:srgbClr val="FFFFFF"/>
+                    </a:solidFill>
+                  </a:tcPr>
+                </a:tc>
+                <a:tc>
+                  <a:txBody>
+                    <a:bodyPr/>
+                    <a:lstStyle/>
+                    <a:p>
+                      <a:pPr algn="ctr"/>
+                      <a:r>
+                        <a:rPr sz="1300" b="0">
+                          <a:solidFill>
+                            <a:srgbClr val="262626"/>
+                          </a:solidFill>
+                          <a:latin typeface="맑은 고딕"/>
+                        </a:rPr>
+                        <a:t>★0 (결함 152)</a:t>
+                      </a:r>
+                    </a:p>
+                  </a:txBody>
+                  <a:tcPr anchor="ctr">
+                    <a:solidFill>
+                      <a:srgbClr val="FFFFFF"/>
+                    </a:solidFill>
+                  </a:tcPr>
+                </a:tc>
+                <a:tc>
+                  <a:txBody>
+                    <a:bodyPr/>
+                    <a:lstStyle/>
+                    <a:p>
+                      <a:pPr algn="ctr"/>
+                      <a:r>
+                        <a:rPr sz="1300" b="1">
+                          <a:solidFill>
+                            <a:srgbClr val="262626"/>
+                          </a:solidFill>
+                          <a:latin typeface="맑은 고딕"/>
+                        </a:rPr>
+                        <a:t>★2</a:t>
+                      </a:r>
+                    </a:p>
+                  </a:txBody>
+                  <a:tcPr anchor="ctr">
+                    <a:solidFill>
+                      <a:srgbClr val="DEEBF7"/>
+                    </a:solidFill>
+                  </a:tcPr>
+                </a:tc>
+              </a:tr>
+              <a:tr h="548640">
+                <a:tc>
+                  <a:txBody>
+                    <a:bodyPr/>
+                    <a:lstStyle/>
+                    <a:p>
+                      <a:pPr algn="l"/>
+                      <a:r>
+                        <a:rPr sz="1300" b="1">
+                          <a:solidFill>
+                            <a:srgbClr val="262626"/>
+                          </a:solidFill>
+                          <a:latin typeface="맑은 고딕"/>
+                        </a:rPr>
+                        <a:t>5. 확장성 (구 스윕)</a:t>
                       </a:r>
                     </a:p>
                   </a:txBody>
@@ -9891,7 +10156,7 @@
               </a:spcAft>
             </a:pPr>
             <a:r>
-              <a:rPr sz="1300" b="1">
+              <a:rPr sz="1250" b="1">
                 <a:solidFill>
                   <a:srgbClr val="262626"/>
                 </a:solidFill>
@@ -9900,13 +10165,13 @@
               <a:t>다자 협상 DP: </a:t>
             </a:r>
             <a:r>
-              <a:rPr sz="1300" b="0">
+              <a:rPr sz="1250" b="0">
                 <a:solidFill>
                   <a:srgbClr val="262626"/>
                 </a:solidFill>
                 <a:latin typeface="맑은 고딕"/>
               </a:rPr>
-              <a:t>"정확한 방안 2 vs 빠르고 은밀한 방안 1-A"의 구조적 트레이드오프 — QA 서열 1위(기능 정확성) 기준 종합 우위는 방안 2</a:t>
+              <a:t>"정확한 방안 2 vs 빠르고 은밀한 1-A" — 서열 1위(FC) 기준 종합 우위는 방안 2 (보완 택틱 적용 시 방안 2+는 FC★5·CF★5·TB★4 전 축 우위, 62번)</a:t>
             </a:r>
           </a:p>
           <a:p>
@@ -9916,7 +10181,7 @@
               </a:spcAft>
             </a:pPr>
             <a:r>
-              <a:rPr sz="1300" b="1">
+              <a:rPr sz="1250" b="1">
                 <a:solidFill>
                   <a:srgbClr val="262626"/>
                 </a:solidFill>
@@ -9925,13 +10190,13 @@
               <a:t>복합 의제 DP: </a:t>
             </a:r>
             <a:r>
-              <a:rPr sz="1300" b="0">
+              <a:rPr sz="1250" b="0">
                 <a:solidFill>
                   <a:srgbClr val="262626"/>
                 </a:solidFill>
                 <a:latin typeface="맑은 고딕"/>
               </a:rPr>
-              <a:t>두 방안이 자원·확장성에서 동급으로 여유 — 변별은 다른 축(정확성·시간 참고 측정)에서 온다</a:t>
+              <a:t>"품질·시간의 pool vs 메모리의 seq2" — 서열 1·4위가 pool 우세라 종합 우위는 pool, 단 의제 18축 이상 한도 초과로 16축 이하 조건부 (63번)</a:t>
             </a:r>
           </a:p>
         </p:txBody>

</xml_diff>

<commit_message>
feat(total),docs(24,60,61,62,64): functional-ext2 정본 승격 — 전 산출물 동기화 (PL 확정 2026-08-14)
변경 대상 리스트업 결과 7건 전부 반영:
1. 코드: nparty_tracks 정본 표기 ext2, aggregate_nparty_ext track 파라메터화(기본 ext2)
2. constants: CF 1:1 앵커 실측 갱신 (e2 0.25→0.2917, 잔여 75%→70.8%)
3. 24 §1.5: 정본 표본 = ext2 (계보 functional→ext→ext2, 시드·플래그 명기), §0/§3.3 앵커
4. 60: 전면 개정 — ext2 정본 run(001421Z) 수치로 요약·부록 A-K 전부 교체
   (FC 0.873★3 vs 0.950★4·승패 259:29, CF 68.3/51.7·e2 0.2917, TB 0.543/0.660·
   결함 0, naive 64.0s, FAQ에 Q10 데이터셋 교체 사유 신설)
5. 61 md+PPT: nparty 스냅샷 ext2 갱신 + 지난 턴 md 편집 누락분 복구
   (RU 로그 사다리 블록·FC/TB 복합 병기·원칙② — PPT에만 반영돼 있던 것)
6. 62: §0/§4/§6 정본 수치 ext2 교체(방안 2+ 0.987★5·92.1%★5·0.383★4·+71/-2),
   §3 반복 이력은 구 정본 기록으로 보존 표기
7. 64: 승격 확정 기록. 테스트 전건 통과.

Co-Authored-By: Claude Fable 5 <noreply@anthropic.com>
</commit_message>
<xml_diff>
--- a/docs/changbae/61-핵심QA-5종-임원-브리핑.pptx
+++ b/docs/changbae/61-핵심QA-5종-임원-브리핑.pptx
@@ -649,7 +649,7 @@
           <a:lstStyle/>
           <a:p>
             <a:r>
-              <a:t>★4 이상 = 일반적인 2인 협상 수준으로 지킨다 (같은 판의 1:1 협상 실측 잔여 = 75%). 관찰자가 여럿인 방안(브로드캐스트류) 비교를 위해 노출 배수 m(1:1 대비 총 노출량)을 보조 병기: 1-A 1.28 vs 방안 2 1.90. 실측 표본: nparty 정본 480건.</a:t>
+              <a:t>★4 이상 = 일반적인 2인 협상 수준으로 지킨다 (같은 판의 1:1 협상 실측 잔여 = 70.8%). 관찰자가 여럿인 방안(브로드캐스트류) 비교를 위해 노출 배수 m(1:1 대비 총 노출량)을 보조 병기: 1-A 1.09 vs 방안 2 1.66. 실측 표본: nparty 정본 functional-ext2 480건.</a:t>
             </a:r>
           </a:p>
         </p:txBody>
@@ -719,7 +719,7 @@
           <a:lstStyle/>
           <a:p>
             <a:r>
-              <a:t>판정 통계 = P95: 시간 품질은 '평소 빠른가'가 아니라 '최악에 가까운 상황에서도 보장되는가'로 판정 — 서비스 SLO가 평균이 아닌 p95/p99 지연으로 정의되는 업계 관행과 동일. 전형 성능(중앙값)·최악값 병기. 결함 1건 = 3인·병목 판(FX-03p-059), ρ&gt;1. 실측 표본: nparty 정본 480건.</a:t>
+              <a:t>판정 통계 = P95: 시간 품질은 '평소 빠른가'가 아니라 '최악에 가까운 상황에서도 보장되는가'로 판정 — 서비스 SLO가 평균이 아닌 p95/p99 지연으로 정의되는 업계 관행과 동일. 전형 성능(중앙값)·최악값 병기. ext2 정본에서는 ρ&gt;1 결함 0건. 실측 표본: nparty 정본 functional-ext2 480건 + composite FIN 500건.</a:t>
             </a:r>
           </a:p>
         </p:txBody>
@@ -5428,7 +5428,7 @@
                 </a:solidFill>
                 <a:latin typeface="맑은 고딕"/>
               </a:rPr>
-              <a:t>다자: 방안 2  0.959 ★5</a:t>
+              <a:t>다자: 방안 2  0.950 ★4</a:t>
             </a:r>
             <a:r>
               <a:rPr sz="1350" b="1">
@@ -5437,7 +5437,7 @@
                 </a:solidFill>
                 <a:latin typeface="맑은 고딕"/>
               </a:rPr>
-              <a:t>  vs  1-A  0.866 ★3</a:t>
+              <a:t>  vs  1-A  0.873 ★3</a:t>
             </a:r>
           </a:p>
           <a:p>
@@ -5453,7 +5453,7 @@
                 </a:solidFill>
                 <a:latin typeface="맑은 고딕"/>
               </a:rPr>
-              <a:t>무작위도 평균 0.86인 판 — 1-A는 무작위와 사실상 동급 (s 0.04 vs 0.71)</a:t>
+              <a:t>무작위도 평균 0.86인 판 — 1-A는 무작위와 거의 동급 (s 0.07 vs 0.63)</a:t>
             </a:r>
           </a:p>
           <a:p>
@@ -7226,7 +7226,7 @@
                 </a:solidFill>
                 <a:latin typeface="맑은 고딕"/>
               </a:rPr>
-              <a:t>무노출 100%와 전량 공개 0% 사이 20%p 등분 · 1:1 협상 실측 잔여 75% = ★4 구간</a:t>
+              <a:t>무노출 100%와 전량 공개 0% 사이 20%p 등분 · 1:1 협상 실측 잔여 70.8% = ★4 구간</a:t>
             </a:r>
           </a:p>
         </p:txBody>
@@ -7299,7 +7299,7 @@
                 </a:solidFill>
                 <a:latin typeface="맑은 고딕"/>
               </a:rPr>
-              <a:t>방안 1-A  67.9% ★4</a:t>
+              <a:t>방안 1-A  68.3% ★4</a:t>
             </a:r>
             <a:r>
               <a:rPr sz="1400" b="1">
@@ -7308,7 +7308,7 @@
                 </a:solidFill>
                 <a:latin typeface="맑은 고딕"/>
               </a:rPr>
-              <a:t>  vs  방안 2  52.4% ★3</a:t>
+              <a:t>  vs  방안 2  51.7% ★3</a:t>
             </a:r>
           </a:p>
           <a:p>
@@ -7340,7 +7340,7 @@
                 </a:solidFill>
                 <a:latin typeface="맑은 고딕"/>
               </a:rPr>
-              <a:t>1-A는 1:1 협상 수준(75%)에 근접 · 방안 2는 합의 후보가 깊은 판에서 29%까지 하락</a:t>
+              <a:t>1-A는 1:1 협상 수준(70.8%)에 근접 · 방안 2는 합의 후보가 깊은 판에서 30%까지 하락</a:t>
             </a:r>
           </a:p>
           <a:p>
@@ -8198,7 +8198,7 @@
                 </a:solidFill>
                 <a:latin typeface="맑은 고딕"/>
               </a:rPr>
-              <a:t>다자: 50인 협상도 약 3초 — naive는 61.5초</a:t>
+              <a:t>다자: 50인 협상도 약 3초 — naive는 64.0초</a:t>
             </a:r>
           </a:p>
           <a:p>
@@ -8214,7 +8214,7 @@
                 </a:solidFill>
                 <a:latin typeface="맑은 고딕"/>
               </a:rPr>
-              <a:t>판정(P95): 1-A 0.556 ★3 vs 방안 2 0.689 ★2 (전형 중앙값은 0.15 vs 0.17로 동급)</a:t>
+              <a:t>판정(P95): 1-A 0.543 ★3 vs 방안 2 0.660 ★2 (전형 중앙값은 0.15 vs 0.17로 동급)</a:t>
             </a:r>
           </a:p>
           <a:p>
@@ -8226,11 +8226,11 @@
             <a:r>
               <a:rPr sz="1150" b="0">
                 <a:solidFill>
-                  <a:srgbClr val="C0392B"/>
-                </a:solidFill>
-                <a:latin typeface="맑은 고딕"/>
-              </a:rPr>
-              <a:t>방안 2는 3인 최악 구간 naive 근접(0.954) + 즉시 결함 1건</a:t>
+                  <a:srgbClr val="262626"/>
+                </a:solidFill>
+                <a:latin typeface="맑은 고딕"/>
+              </a:rPr>
+              <a:t>방안 2는 3인 소규모 최악 구간에서 naive 근접(P95 0.867)</a:t>
             </a:r>
           </a:p>
           <a:p>
@@ -9500,7 +9500,7 @@
                           </a:solidFill>
                           <a:latin typeface="맑은 고딕"/>
                         </a:rPr>
-                        <a:t>★5</a:t>
+                        <a:t>★4</a:t>
                       </a:r>
                     </a:p>
                   </a:txBody>
@@ -9642,7 +9642,7 @@
                           </a:solidFill>
                           <a:latin typeface="맑은 고딕"/>
                         </a:rPr>
-                        <a:t>★2 (결함 1)</a:t>
+                        <a:t>★2</a:t>
                       </a:r>
                     </a:p>
                   </a:txBody>
@@ -10171,7 +10171,7 @@
                 </a:solidFill>
                 <a:latin typeface="맑은 고딕"/>
               </a:rPr>
-              <a:t>"정확한 방안 2 vs 빠르고 은밀한 1-A" — 서열 1위(FC) 기준 종합 우위는 방안 2 (보완 택틱 적용 시 방안 2+는 FC★5·CF★5·TB★4 전 축 우위, 62번)</a:t>
+              <a:t>"정확한 방안 2 vs 빠르고 은밀한 1-A" — 서열 1위(FC) 기준 종합 우위는 방안 2 (택틱 적용판 방안 2+는 FC 0.987★5·CF 92.1%★5·TB 0.383★4 전 축 우위, 62번)</a:t>
             </a:r>
           </a:p>
           <a:p>

</xml_diff>

<commit_message>
docs(61),feat(total): QA 이해 보조 그림 5종 — P95 설명 포함 (PL 지시, 이해도 취지)
전부 정본 실측 데이터의 재집계 그림 (plot_qa_explainers.py, 한글 라벨 Noto CJK KR):
- P95 설명: 방안 2 ρ ECDF에 중앙값/P95/'가장 느린 5%' 주석 — 판정 통계의 직관화.
  PPT에는 전용 보충 슬라이드(TB 다음)로 삽입, RU에도 같은 원리 적용 명시
- FC: 달성률 눈금 위 실측 위치 (별점 대역 + 무작위 R̄ 0.86 기준선 + 경계 직하 표기)
- RU: 한도 128MB 유도 (앱 힙 256MB 분해 막대)
- CF: 후보 12칸 순위표의 공개/비밀 (실측 평균 3.8개 vs 5.8개 → 잔여 68%/52%)
- SC: 조합 폭발 실측 곡선 (FIN 중앙 S, CR 통제 구간 주석, 20축 약 1,600억)
61 md 각 절 + PPT(9슬라이드) 동시 삽입. 라벨 겹침 검수 반영.

Co-Authored-By: Claude Fable 5 <noreply@anthropic.com>
</commit_message>
<xml_diff>
--- a/docs/changbae/61-핵심QA-5종-임원-브리핑.pptx
+++ b/docs/changbae/61-핵심QA-5종-임원-브리핑.pptx
@@ -13,6 +13,7 @@
     <p:sldId id="261" r:id="rId13"/>
     <p:sldId id="262" r:id="rId14"/>
     <p:sldId id="263" r:id="rId15"/>
+    <p:sldId id="264" r:id="rId16"/>
   </p:sldIdLst>
   <p:sldSz cx="12191695" cy="6858000" type="screen4x3"/>
   <p:notesSz cx="6858000" cy="9144000"/>
@@ -789,7 +790,7 @@
           <a:lstStyle/>
           <a:p>
             <a:r>
-              <a:t>로그 등분의 실제 수열: 4·5.0·6.2·7.7·9.6·12의 반올림 (근거 상세: 24 §5.3-a — 여행급 협의 축 열거, Miller 1956, ANAC 실세계 소재 도메인 규모). 실측 표본: composite 정본 4-10축 스윕.</a:t>
+              <a:t>대표 그림: 방안 2의 시간 비율 ρ 누적분포 (nparty 정본 480케이스 실측). 같은 원리가 RU(사용률 r P95)에도 적용된다. 원본: docs/changbae/figures/61/fig-p95-explain.png · 생성 plot_qa_explainers.py</a:t>
             </a:r>
           </a:p>
         </p:txBody>
@@ -815,6 +816,76 @@
 </file>
 
 <file path=ppt/notesSlides/notesSlide6.xml><?xml version="1.0" encoding="utf-8"?>
+<p:notes xmlns:a="http://schemas.openxmlformats.org/drawingml/2006/main" xmlns:p="http://schemas.openxmlformats.org/presentationml/2006/main" xmlns:r="http://schemas.openxmlformats.org/officeDocument/2006/relationships">
+  <p:cSld>
+    <p:spTree>
+      <p:nvGrpSpPr>
+        <p:cNvPr id="1" name=""/>
+        <p:cNvGrpSpPr/>
+        <p:nvPr/>
+      </p:nvGrpSpPr>
+      <p:grpSpPr>
+        <a:xfrm>
+          <a:off x="0" y="0"/>
+          <a:ext cx="0" cy="0"/>
+          <a:chOff x="0" y="0"/>
+          <a:chExt cx="0" cy="0"/>
+        </a:xfrm>
+      </p:grpSpPr>
+      <p:sp>
+        <p:nvSpPr>
+          <p:cNvPr id="2" name="Slide Image Placeholder 1"/>
+          <p:cNvSpPr>
+            <a:spLocks noGrp="1"/>
+          </p:cNvSpPr>
+          <p:nvPr>
+            <p:ph type="sldImg" idx="2"/>
+          </p:nvPr>
+        </p:nvSpPr>
+        <p:spPr/>
+      </p:sp>
+      <p:sp>
+        <p:nvSpPr>
+          <p:cNvPr id="3" name="Notes Placeholder 2"/>
+          <p:cNvSpPr>
+            <a:spLocks noGrp="1"/>
+          </p:cNvSpPr>
+          <p:nvPr>
+            <p:ph type="body" idx="3" sz="quarter"/>
+          </p:nvPr>
+        </p:nvSpPr>
+        <p:spPr/>
+        <p:txBody>
+          <a:bodyPr/>
+          <a:lstStyle/>
+          <a:p>
+            <a:r>
+              <a:t>로그 등분의 실제 수열: 4·5.0·6.2·7.7·9.6·12의 반올림 (근거 상세: 24 §5.3-a — 여행급 협의 축 열거, Miller 1956, ANAC 실세계 소재 도메인 규모). 실측 표본: composite 정본 4-10축 스윕.</a:t>
+            </a:r>
+          </a:p>
+        </p:txBody>
+      </p:sp>
+      <p:sp>
+        <p:nvSpPr>
+          <p:cNvPr id="4" name="Slide Number Placeholder 3"/>
+          <p:cNvSpPr>
+            <a:spLocks noGrp="1"/>
+          </p:cNvSpPr>
+          <p:nvPr>
+            <p:ph type="sldNum" idx="5" sz="quarter"/>
+          </p:nvPr>
+        </p:nvSpPr>
+        <p:spPr/>
+      </p:sp>
+    </p:spTree>
+  </p:cSld>
+  <p:clrMapOvr>
+    <a:masterClrMapping/>
+  </p:clrMapOvr>
+</p:notes>
+</file>
+
+<file path=ppt/notesSlides/notesSlide7.xml><?xml version="1.0" encoding="utf-8"?>
 <p:notes xmlns:a="http://schemas.openxmlformats.org/drawingml/2006/main" xmlns:p="http://schemas.openxmlformats.org/presentationml/2006/main" xmlns:r="http://schemas.openxmlformats.org/officeDocument/2006/relationships">
   <p:cSld>
     <p:spTree>
@@ -4940,9 +5011,33 @@
           </a:p>
         </p:txBody>
       </p:sp>
-      <p:sp>
-        <p:nvSpPr>
-          <p:cNvPr id="5" name="Rectangle 4"/>
+      <p:pic>
+        <p:nvPicPr>
+          <p:cNvPr id="5" name="Picture 4" descr="fig-fc-scale.png"/>
+          <p:cNvPicPr>
+            <a:picLocks noChangeAspect="1"/>
+          </p:cNvPicPr>
+          <p:nvPr/>
+        </p:nvPicPr>
+        <p:blipFill>
+          <a:blip r:embed="rId2"/>
+          <a:stretch>
+            <a:fillRect/>
+          </a:stretch>
+        </p:blipFill>
+        <p:spPr>
+          <a:xfrm>
+            <a:off x="457200" y="4956048"/>
+            <a:ext cx="5074920" cy="1776222"/>
+          </a:xfrm>
+          <a:prstGeom prst="rect">
+            <a:avLst/>
+          </a:prstGeom>
+        </p:spPr>
+      </p:pic>
+      <p:sp>
+        <p:nvSpPr>
+          <p:cNvPr id="6" name="Rectangle 5"/>
           <p:cNvSpPr/>
           <p:nvPr/>
         </p:nvSpPr>
@@ -4997,7 +5092,7 @@
       </p:sp>
       <p:graphicFrame>
         <p:nvGraphicFramePr>
-          <p:cNvPr id="6" name="Table 5"/>
+          <p:cNvPr id="7" name="Table 6"/>
           <p:cNvGraphicFramePr>
             <a:graphicFrameLocks noGrp="1"/>
           </p:cNvGraphicFramePr>
@@ -5307,7 +5402,7 @@
       </p:graphicFrame>
       <p:sp>
         <p:nvSpPr>
-          <p:cNvPr id="7" name="Rectangle 6"/>
+          <p:cNvPr id="8" name="Rectangle 7"/>
           <p:cNvSpPr/>
           <p:nvPr/>
         </p:nvSpPr>
@@ -5362,7 +5457,7 @@
       </p:sp>
       <p:sp>
         <p:nvSpPr>
-          <p:cNvPr id="8" name="Rectangle 7"/>
+          <p:cNvPr id="9" name="Rectangle 8"/>
           <p:cNvSpPr/>
           <p:nvPr/>
         </p:nvSpPr>
@@ -5885,20 +5980,44 @@
               </a:spcAft>
             </a:pPr>
             <a:r>
-              <a:rPr sz="1250" b="0">
-                <a:solidFill>
-                  <a:srgbClr val="262626"/>
-                </a:solidFill>
-                <a:latin typeface="맑은 고딕"/>
-              </a:rPr>
-              <a:t>한도 128MB는 안드로이드 앱 힙 상한에서 유도 (상세: 발표 노트)</a:t>
-            </a:r>
-          </a:p>
-        </p:txBody>
-      </p:sp>
-      <p:sp>
-        <p:nvSpPr>
-          <p:cNvPr id="5" name="Rectangle 4"/>
+              <a:rPr sz="1150" b="0">
+                <a:solidFill>
+                  <a:srgbClr val="595959"/>
+                </a:solidFill>
+                <a:latin typeface="맑은 고딕"/>
+              </a:rPr>
+              <a:t>한도 128MB의 유도는 아래 그림</a:t>
+            </a:r>
+          </a:p>
+        </p:txBody>
+      </p:sp>
+      <p:pic>
+        <p:nvPicPr>
+          <p:cNvPr id="5" name="Picture 4" descr="fig-ru-budget.png"/>
+          <p:cNvPicPr>
+            <a:picLocks noChangeAspect="1"/>
+          </p:cNvPicPr>
+          <p:nvPr/>
+        </p:nvPicPr>
+        <p:blipFill>
+          <a:blip r:embed="rId2"/>
+          <a:stretch>
+            <a:fillRect/>
+          </a:stretch>
+        </p:blipFill>
+        <p:spPr>
+          <a:xfrm>
+            <a:off x="457200" y="4956048"/>
+            <a:ext cx="5074920" cy="1776222"/>
+          </a:xfrm>
+          <a:prstGeom prst="rect">
+            <a:avLst/>
+          </a:prstGeom>
+        </p:spPr>
+      </p:pic>
+      <p:sp>
+        <p:nvSpPr>
+          <p:cNvPr id="6" name="Rectangle 5"/>
           <p:cNvSpPr/>
           <p:nvPr/>
         </p:nvSpPr>
@@ -5953,7 +6072,7 @@
       </p:sp>
       <p:graphicFrame>
         <p:nvGraphicFramePr>
-          <p:cNvPr id="6" name="Table 5"/>
+          <p:cNvPr id="7" name="Table 6"/>
           <p:cNvGraphicFramePr>
             <a:graphicFrameLocks noGrp="1"/>
           </p:cNvGraphicFramePr>
@@ -6263,7 +6382,7 @@
       </p:graphicFrame>
       <p:sp>
         <p:nvSpPr>
-          <p:cNvPr id="7" name="Rectangle 6"/>
+          <p:cNvPr id="8" name="Rectangle 7"/>
           <p:cNvSpPr/>
           <p:nvPr/>
         </p:nvSpPr>
@@ -6318,7 +6437,7 @@
       </p:sp>
       <p:sp>
         <p:nvSpPr>
-          <p:cNvPr id="8" name="Rectangle 7"/>
+          <p:cNvPr id="9" name="Rectangle 8"/>
           <p:cNvSpPr/>
           <p:nvPr/>
         </p:nvSpPr>
@@ -6811,9 +6930,33 @@
           </a:p>
         </p:txBody>
       </p:sp>
-      <p:sp>
-        <p:nvSpPr>
-          <p:cNvPr id="5" name="Rectangle 4"/>
+      <p:pic>
+        <p:nvPicPr>
+          <p:cNvPr id="5" name="Picture 4" descr="fig-cf-secret.png"/>
+          <p:cNvPicPr>
+            <a:picLocks noChangeAspect="1"/>
+          </p:cNvPicPr>
+          <p:nvPr/>
+        </p:nvPicPr>
+        <p:blipFill>
+          <a:blip r:embed="rId2"/>
+          <a:stretch>
+            <a:fillRect/>
+          </a:stretch>
+        </p:blipFill>
+        <p:spPr>
+          <a:xfrm>
+            <a:off x="457200" y="4956048"/>
+            <a:ext cx="5074920" cy="1776222"/>
+          </a:xfrm>
+          <a:prstGeom prst="rect">
+            <a:avLst/>
+          </a:prstGeom>
+        </p:spPr>
+      </p:pic>
+      <p:sp>
+        <p:nvSpPr>
+          <p:cNvPr id="6" name="Rectangle 5"/>
           <p:cNvSpPr/>
           <p:nvPr/>
         </p:nvSpPr>
@@ -6868,7 +7011,7 @@
       </p:sp>
       <p:graphicFrame>
         <p:nvGraphicFramePr>
-          <p:cNvPr id="6" name="Table 5"/>
+          <p:cNvPr id="7" name="Table 6"/>
           <p:cNvGraphicFramePr>
             <a:graphicFrameLocks noGrp="1"/>
           </p:cNvGraphicFramePr>
@@ -7178,7 +7321,7 @@
       </p:graphicFrame>
       <p:sp>
         <p:nvSpPr>
-          <p:cNvPr id="7" name="Rectangle 6"/>
+          <p:cNvPr id="8" name="Rectangle 7"/>
           <p:cNvSpPr/>
           <p:nvPr/>
         </p:nvSpPr>
@@ -7233,7 +7376,7 @@
       </p:sp>
       <p:sp>
         <p:nvSpPr>
-          <p:cNvPr id="8" name="Rectangle 7"/>
+          <p:cNvPr id="9" name="Rectangle 8"/>
           <p:cNvSpPr/>
           <p:nvPr/>
         </p:nvSpPr>
@@ -8362,6 +8505,203 @@
                 </a:solidFill>
                 <a:latin typeface="맑은 고딕"/>
               </a:rPr>
+              <a:t>보충  </a:t>
+            </a:r>
+            <a:r>
+              <a:rPr sz="2200" b="1">
+                <a:solidFill>
+                  <a:srgbClr val="FFFFFF"/>
+                </a:solidFill>
+                <a:latin typeface="맑은 고딕"/>
+              </a:rPr>
+              <a:t>P95 판정 읽는 법 — 시간·자원 QA의 판정 통계</a:t>
+            </a:r>
+          </a:p>
+        </p:txBody>
+      </p:sp>
+      <p:sp>
+        <p:nvSpPr>
+          <p:cNvPr id="3" name="Rectangle 2"/>
+          <p:cNvSpPr/>
+          <p:nvPr/>
+        </p:nvSpPr>
+        <p:spPr>
+          <a:xfrm>
+            <a:off x="411480" y="1051560"/>
+            <a:ext cx="11384280" cy="1051560"/>
+          </a:xfrm>
+          <a:prstGeom prst="rect">
+            <a:avLst/>
+          </a:prstGeom>
+          <a:noFill/>
+          <a:ln>
+            <a:noFill/>
+          </a:ln>
+          <a:effectLst/>
+        </p:spPr>
+        <p:style>
+          <a:lnRef idx="1">
+            <a:schemeClr val="accent1"/>
+          </a:lnRef>
+          <a:fillRef idx="3">
+            <a:schemeClr val="accent1"/>
+          </a:fillRef>
+          <a:effectRef idx="2">
+            <a:schemeClr val="accent1"/>
+          </a:effectRef>
+          <a:fontRef idx="minor">
+            <a:schemeClr val="lt1"/>
+          </a:fontRef>
+        </p:style>
+        <p:txBody>
+          <a:bodyPr rtlCol="0" anchor="t" wrap="square" lIns="76200" rIns="76200" tIns="38100" bIns="38100"/>
+          <a:lstStyle/>
+          <a:p>
+            <a:pPr algn="ctr">
+              <a:spcAft>
+                <a:spcPts val="400"/>
+              </a:spcAft>
+            </a:pPr>
+            <a:r>
+              <a:rPr sz="1400" b="0">
+                <a:solidFill>
+                  <a:srgbClr val="262626"/>
+                </a:solidFill>
+                <a:latin typeface="맑은 고딕"/>
+              </a:rPr>
+              <a:t>케이스를 빠른 순으로 쌓아 올린 곡선(누적분포)에서 </a:t>
+            </a:r>
+            <a:r>
+              <a:rPr sz="1400" b="1">
+                <a:solidFill>
+                  <a:srgbClr val="1F3864"/>
+                </a:solidFill>
+                <a:latin typeface="맑은 고딕"/>
+              </a:rPr>
+              <a:t>95% 높이에 닿는 지점이 P95</a:t>
+            </a:r>
+            <a:r>
+              <a:rPr sz="1400" b="0">
+                <a:solidFill>
+                  <a:srgbClr val="262626"/>
+                </a:solidFill>
+                <a:latin typeface="맑은 고딕"/>
+              </a:rPr>
+              <a:t> — "가장 느린 5%가 시작되는 경계"다.</a:t>
+            </a:r>
+          </a:p>
+          <a:p>
+            <a:pPr>
+              <a:spcAft>
+                <a:spcPts val="0"/>
+              </a:spcAft>
+            </a:pPr>
+            <a:r>
+              <a:rPr sz="1300" b="0">
+                <a:solidFill>
+                  <a:srgbClr val="262626"/>
+                </a:solidFill>
+                <a:latin typeface="맑은 고딕"/>
+              </a:rPr>
+              <a:t>중앙값(전형 성능)이 아니라 이 값으로 별점을 매긴다 — 사용자가 기억하는 것은 평균이 아니라 느렸던 경험이기 때문 (서비스 SLO의 p95/p99 관행)</a:t>
+            </a:r>
+          </a:p>
+        </p:txBody>
+      </p:sp>
+      <p:pic>
+        <p:nvPicPr>
+          <p:cNvPr id="4" name="Picture 3" descr="fig-p95-explain.png"/>
+          <p:cNvPicPr>
+            <a:picLocks noChangeAspect="1"/>
+          </p:cNvPicPr>
+          <p:nvPr/>
+        </p:nvPicPr>
+        <p:blipFill>
+          <a:blip r:embed="rId2"/>
+          <a:stretch>
+            <a:fillRect/>
+          </a:stretch>
+        </p:blipFill>
+        <p:spPr>
+          <a:xfrm>
+            <a:off x="2624328" y="2240280"/>
+            <a:ext cx="6949440" cy="4246880"/>
+          </a:xfrm>
+          <a:prstGeom prst="rect">
+            <a:avLst/>
+          </a:prstGeom>
+        </p:spPr>
+      </p:pic>
+    </p:spTree>
+  </p:cSld>
+  <p:clrMapOvr>
+    <a:masterClrMapping/>
+  </p:clrMapOvr>
+</p:sld>
+</file>
+
+<file path=ppt/slides/slide8.xml><?xml version="1.0" encoding="utf-8"?>
+<p:sld xmlns:a="http://schemas.openxmlformats.org/drawingml/2006/main" xmlns:p="http://schemas.openxmlformats.org/presentationml/2006/main" xmlns:r="http://schemas.openxmlformats.org/officeDocument/2006/relationships">
+  <p:cSld>
+    <p:spTree>
+      <p:nvGrpSpPr>
+        <p:cNvPr id="1" name=""/>
+        <p:cNvGrpSpPr/>
+        <p:nvPr/>
+      </p:nvGrpSpPr>
+      <p:grpSpPr/>
+      <p:sp>
+        <p:nvSpPr>
+          <p:cNvPr id="2" name="Rectangle 1"/>
+          <p:cNvSpPr/>
+          <p:nvPr/>
+        </p:nvSpPr>
+        <p:spPr>
+          <a:xfrm>
+            <a:off x="0" y="0"/>
+            <a:ext cx="12191695" cy="868680"/>
+          </a:xfrm>
+          <a:prstGeom prst="rect">
+            <a:avLst/>
+          </a:prstGeom>
+          <a:solidFill>
+            <a:srgbClr val="1F3864"/>
+          </a:solidFill>
+          <a:ln>
+            <a:noFill/>
+          </a:ln>
+          <a:effectLst/>
+        </p:spPr>
+        <p:style>
+          <a:lnRef idx="1">
+            <a:schemeClr val="accent1"/>
+          </a:lnRef>
+          <a:fillRef idx="3">
+            <a:schemeClr val="accent1"/>
+          </a:fillRef>
+          <a:effectRef idx="2">
+            <a:schemeClr val="accent1"/>
+          </a:effectRef>
+          <a:fontRef idx="minor">
+            <a:schemeClr val="lt1"/>
+          </a:fontRef>
+        </p:style>
+        <p:txBody>
+          <a:bodyPr rtlCol="0" anchor="ctr" wrap="square" lIns="76200" rIns="76200" tIns="38100" bIns="38100"/>
+          <a:lstStyle/>
+          <a:p>
+            <a:pPr algn="ctr">
+              <a:spcAft>
+                <a:spcPts val="0"/>
+              </a:spcAft>
+            </a:pPr>
+            <a:r>
+              <a:rPr sz="2200" b="1">
+                <a:solidFill>
+                  <a:srgbClr val="DEEBF7"/>
+                </a:solidFill>
+                <a:latin typeface="맑은 고딕"/>
+              </a:rPr>
               <a:t>핵심 5위  </a:t>
             </a:r>
             <a:r>
@@ -8657,9 +8997,33 @@
           </a:p>
         </p:txBody>
       </p:sp>
-      <p:sp>
-        <p:nvSpPr>
-          <p:cNvPr id="5" name="Rectangle 4"/>
+      <p:pic>
+        <p:nvPicPr>
+          <p:cNvPr id="5" name="Picture 4" descr="fig-sc-explosion.png"/>
+          <p:cNvPicPr>
+            <a:picLocks noChangeAspect="1"/>
+          </p:cNvPicPr>
+          <p:nvPr/>
+        </p:nvPicPr>
+        <p:blipFill>
+          <a:blip r:embed="rId2"/>
+          <a:stretch>
+            <a:fillRect/>
+          </a:stretch>
+        </p:blipFill>
+        <p:spPr>
+          <a:xfrm>
+            <a:off x="457200" y="4956048"/>
+            <a:ext cx="5074920" cy="1776222"/>
+          </a:xfrm>
+          <a:prstGeom prst="rect">
+            <a:avLst/>
+          </a:prstGeom>
+        </p:spPr>
+      </p:pic>
+      <p:sp>
+        <p:nvSpPr>
+          <p:cNvPr id="6" name="Rectangle 5"/>
           <p:cNvSpPr/>
           <p:nvPr/>
         </p:nvSpPr>
@@ -8714,7 +9078,7 @@
       </p:sp>
       <p:graphicFrame>
         <p:nvGraphicFramePr>
-          <p:cNvPr id="6" name="Table 5"/>
+          <p:cNvPr id="7" name="Table 6"/>
           <p:cNvGraphicFramePr>
             <a:graphicFrameLocks noGrp="1"/>
           </p:cNvGraphicFramePr>
@@ -9024,7 +9388,7 @@
       </p:graphicFrame>
       <p:sp>
         <p:nvSpPr>
-          <p:cNvPr id="7" name="Rectangle 6"/>
+          <p:cNvPr id="8" name="Rectangle 7"/>
           <p:cNvSpPr/>
           <p:nvPr/>
         </p:nvSpPr>
@@ -9079,7 +9443,7 @@
       </p:sp>
       <p:sp>
         <p:nvSpPr>
-          <p:cNvPr id="8" name="Rectangle 7"/>
+          <p:cNvPr id="9" name="Rectangle 8"/>
           <p:cNvSpPr/>
           <p:nvPr/>
         </p:nvSpPr>
@@ -9215,7 +9579,7 @@
 </p:sld>
 </file>
 
-<file path=ppt/slides/slide8.xml><?xml version="1.0" encoding="utf-8"?>
+<file path=ppt/slides/slide9.xml><?xml version="1.0" encoding="utf-8"?>
 <p:sld xmlns:a="http://schemas.openxmlformats.org/drawingml/2006/main" xmlns:p="http://schemas.openxmlformats.org/presentationml/2006/main" xmlns:r="http://schemas.openxmlformats.org/officeDocument/2006/relationships">
   <p:cSld>
     <p:spTree>

</xml_diff>

<commit_message>
feat(total),docs(24,63,65,61): RU 별점 사다리 재개정 — [1%,100%] 로그 4등분 (PL 확정 2026-08-14)
★5 = ≤1%: 실측 축당 성장률(×2.06-2.12) 기준 기준 시나리오(4축)가 실사용 최대
(≈10축, SC-의제와 같은 앵커)까지 자라는 성장 배수(약 100배)를 견디는 여유 —
'협상이 실사용 최대 규모로 커져도 한도 안'. 1칸 = √10 ≈ 3.2배 ≈ 의제 1.6개.
데케이드판(★5=0.01%)의 근거 부족·직관 불일치(0.3% 사용이 ★3) 해소.
- constants band_ru_usage [1e-2, 10^-1.5, 1e-1, 10^-0.5, 1.0] + 유도 기록,
  테스트 재기준(0.30%→★5, 6.4%→★3 등) 전건 통과
- 24 §0/§2.8 재개정(사다리 표·재개정 근거 명문화), 63 별점 재환산(seq2 P95
  0.30% ★3→★5·중앙/최악 ★5·★5 기준 1%, 측정값 불변·갱신 노트),
  65/61 md+PPT 스코어카드·사다리 동기화

Co-Authored-By: Claude Fable 5 <noreply@anthropic.com>
</commit_message>
<xml_diff>
--- a/docs/changbae/61-핵심QA-5종-임원-브리핑.pptx
+++ b/docs/changbae/61-핵심QA-5종-임원-브리핑.pptx
@@ -6865,7 +6865,7 @@
                 </a:solidFill>
                 <a:latin typeface="맑은 고딕"/>
               </a:rPr>
-              <a:t>판정 = P95 (OOM은 꼬리 사건) · 지수 성장 도메인이라 별점은 로그 계단 — 1칸 = 10배 여유</a:t>
+              <a:t>판정 = P95 (OOM은 꼬리 사건) · 별점 = [1%,100%] 로그 4등분 — ★5 = 실사용 최대까지 성장 여유</a:t>
             </a:r>
           </a:p>
           <a:p>
@@ -7145,52 +7145,6 @@
                           </a:solidFill>
                           <a:latin typeface="맑은 고딕"/>
                         </a:rPr>
-                        <a:t>≤0.01%</a:t>
-                      </a:r>
-                    </a:p>
-                  </a:txBody>
-                  <a:tcPr marL="25400" marR="25400" marT="12700" marB="12700" anchor="ctr">
-                    <a:solidFill>
-                      <a:srgbClr val="FFFFFF"/>
-                    </a:solidFill>
-                  </a:tcPr>
-                </a:tc>
-                <a:tc>
-                  <a:txBody>
-                    <a:bodyPr/>
-                    <a:lstStyle/>
-                    <a:p>
-                      <a:pPr algn="ctr"/>
-                      <a:r>
-                        <a:rPr sz="1100" b="0">
-                          <a:solidFill>
-                            <a:srgbClr val="262626"/>
-                          </a:solidFill>
-                          <a:latin typeface="맑은 고딕"/>
-                        </a:rPr>
-                        <a:t>≤0.1%</a:t>
-                      </a:r>
-                    </a:p>
-                  </a:txBody>
-                  <a:tcPr marL="25400" marR="25400" marT="12700" marB="12700" anchor="ctr">
-                    <a:solidFill>
-                      <a:srgbClr val="FFFFFF"/>
-                    </a:solidFill>
-                  </a:tcPr>
-                </a:tc>
-                <a:tc>
-                  <a:txBody>
-                    <a:bodyPr/>
-                    <a:lstStyle/>
-                    <a:p>
-                      <a:pPr algn="ctr"/>
-                      <a:r>
-                        <a:rPr sz="1100" b="0">
-                          <a:solidFill>
-                            <a:srgbClr val="262626"/>
-                          </a:solidFill>
-                          <a:latin typeface="맑은 고딕"/>
-                        </a:rPr>
                         <a:t>≤1%</a:t>
                       </a:r>
                     </a:p>
@@ -7214,7 +7168,53 @@
                           </a:solidFill>
                           <a:latin typeface="맑은 고딕"/>
                         </a:rPr>
+                        <a:t>≤3.2%</a:t>
+                      </a:r>
+                    </a:p>
+                  </a:txBody>
+                  <a:tcPr marL="25400" marR="25400" marT="12700" marB="12700" anchor="ctr">
+                    <a:solidFill>
+                      <a:srgbClr val="FFFFFF"/>
+                    </a:solidFill>
+                  </a:tcPr>
+                </a:tc>
+                <a:tc>
+                  <a:txBody>
+                    <a:bodyPr/>
+                    <a:lstStyle/>
+                    <a:p>
+                      <a:pPr algn="ctr"/>
+                      <a:r>
+                        <a:rPr sz="1100" b="0">
+                          <a:solidFill>
+                            <a:srgbClr val="262626"/>
+                          </a:solidFill>
+                          <a:latin typeface="맑은 고딕"/>
+                        </a:rPr>
                         <a:t>≤10%</a:t>
+                      </a:r>
+                    </a:p>
+                  </a:txBody>
+                  <a:tcPr marL="25400" marR="25400" marT="12700" marB="12700" anchor="ctr">
+                    <a:solidFill>
+                      <a:srgbClr val="FFFFFF"/>
+                    </a:solidFill>
+                  </a:tcPr>
+                </a:tc>
+                <a:tc>
+                  <a:txBody>
+                    <a:bodyPr/>
+                    <a:lstStyle/>
+                    <a:p>
+                      <a:pPr algn="ctr"/>
+                      <a:r>
+                        <a:rPr sz="1100" b="0">
+                          <a:solidFill>
+                            <a:srgbClr val="262626"/>
+                          </a:solidFill>
+                          <a:latin typeface="맑은 고딕"/>
+                        </a:rPr>
+                        <a:t>≤32%</a:t>
                       </a:r>
                     </a:p>
                   </a:txBody>
@@ -7325,7 +7325,7 @@
                 </a:solidFill>
                 <a:latin typeface="맑은 고딕"/>
               </a:rPr>
-              <a:t>로그(데케이드) 사다리 — 선형 등분은 지수 도메인에서 포화 (24 §2.8 개정 2026-08-13)</a:t>
+              <a:t>[1%,100%] 로그 4등분 — ★5 = 실사용 최대까지 성장(약 100배) 여유 (24 §2.8 재개정 2026-08-14)</a:t>
             </a:r>
           </a:p>
         </p:txBody>
@@ -7398,7 +7398,7 @@
                 </a:solidFill>
                 <a:latin typeface="맑은 고딕"/>
               </a:rPr>
-              <a:t>seq2  P95 0.30% ★3</a:t>
+              <a:t>seq2  P95 0.30% ★5</a:t>
             </a:r>
             <a:r>
               <a:rPr sz="1400" b="1">
@@ -11173,7 +11173,7 @@
                           </a:solidFill>
                           <a:latin typeface="맑은 고딕"/>
                         </a:rPr>
-                        <a:t>★3</a:t>
+                        <a:t>★5</a:t>
                       </a:r>
                     </a:p>
                   </a:txBody>

</xml_diff>

<commit_message>
docs+qa(ru): composite RU 별점을 P95·최대값 2케이스 병행 보고로 확장 (PL 지시 2026-08-14, 24 §2.8 3차)
- 24 §0/§2.8: 표본 별점 = 2케이스 병행 산출 (케이스 1 P95 = 꼬리 여유 · 케이스 2 최대 = 최악 안전) — 단일 인용 대표는 최대값(보수 기준), 개정 이력 3단계 기록
- ru.py aggregate: docstring·note 병행 규칙 반영 (stars_p95·stars_max 산출은 기존 유지)
- 63: 요약표·D1·분위표를 2케이스 행으로 재구성 (seq2 0.30%★5/0.96%★5 · pool 48.2%★1/3,692%★0), RU ECDF에 P95·max 판정점 동시 표시 (figures/63 재수출)
- 66: P6 판정표 2케이스 (P95 1.32%★4 37배 / 최대 4.0%★3 923배 — 초과 11→0건)
- 65/61: RU 슬라이드·비교표·종합표에 ①P95 ②최대 행 병행 + PPT 재생성 (각 14슬라이드)

Co-Authored-By: Claude Fable 5 <noreply@anthropic.com>
</commit_message>
<xml_diff>
--- a/docs/changbae/61-핵심QA-5종-임원-브리핑.pptx
+++ b/docs/changbae/61-핵심QA-5종-임원-브리핑.pptx
@@ -6666,7 +6666,7 @@
                 </a:solidFill>
                 <a:latin typeface="맑은 고딕"/>
               </a:rPr>
-              <a:t>협상 중 가장 무거운 단말의 순간 메모리 피크가, 협상 몫(128MB)의 몇 %인가 — 사용률 r의 최대값으로 판정</a:t>
+              <a:t>협상 중 가장 무거운 단말의 순간 메모리 피크가, 협상 몫(128MB)의 몇 %인가 — 사용률 r (P95·최대 2케이스 병행)</a:t>
             </a:r>
           </a:p>
         </p:txBody>
@@ -6865,7 +6865,7 @@
                 </a:solidFill>
                 <a:latin typeface="맑은 고딕"/>
               </a:rPr>
-              <a:t>판정 = 최대값 (OOM은 최악 1건이 크리티컬 — P95·중앙 병기) · 별점 = [1%,100%] 로그 4등분 — ★5 = 실사용 최대까지 성장 여유</a:t>
+              <a:t>별점 = P95·최대 2케이스 병행 (① 꼬리 여유 ② 최악 안전 — 단일 인용 대표는 최대) · 사다리 = [1%,100%] 로그 4등분</a:t>
             </a:r>
           </a:p>
           <a:p>
@@ -7392,22 +7392,22 @@
               </a:spcAft>
             </a:pPr>
             <a:r>
-              <a:rPr sz="1400" b="1">
+              <a:rPr sz="1300" b="1">
                 <a:solidFill>
                   <a:srgbClr val="2E74B5"/>
                 </a:solidFill>
                 <a:latin typeface="맑은 고딕"/>
               </a:rPr>
-              <a:t>seq2  r 최대 0.96% ★5</a:t>
-            </a:r>
-            <a:r>
-              <a:rPr sz="1400" b="1">
+              <a:t>seq2  P95 0.30% ★5 · 최대 0.96% ★5</a:t>
+            </a:r>
+            <a:r>
+              <a:rPr sz="1300" b="1">
                 <a:solidFill>
                   <a:srgbClr val="262626"/>
                 </a:solidFill>
                 <a:latin typeface="맑은 고딕"/>
               </a:rPr>
-              <a:t>  vs  pool  3,692% ★0</a:t>
+              <a:t>  vs  pool  P95 48.2% ★1 · 최대 3,692% ★0</a:t>
             </a:r>
           </a:p>
           <a:p>
@@ -7439,7 +7439,7 @@
                 </a:solidFill>
                 <a:latin typeface="맑은 고딕"/>
               </a:rPr>
-              <a:t>seq2는 최악 1.2MB·P95 0.39MB(한도의 1% 미만) · pool은 12축 0.5MB → 20축 110MB로 지수 성장 (P95 병기: 0.30% vs 48.2%)</a:t>
+              <a:t>seq2는 최악 1.2MB·P95 0.39MB(한도의 1% 미만) · pool은 12축 0.5MB → 20축 110MB로 지수 성장</a:t>
             </a:r>
           </a:p>
           <a:p>

</xml_diff>

<commit_message>
docs+qa(ru): RU 별점 사다리를 20%p 등분으로 확정 (PL 확정 2026-08-14 — TB·CF와 눈금 통일)
- constants: band_ru_usage = [0.2,0.4,0.6,0.8,1.0] (RU_STEP 0.20). 구 로그([1%,100%] 4등분)는 band_ru_usage_log()로, 구 15%p는 band_ru_usage_linear()로 이력 보존
- 24 §0/§2.8: 사다리 3차 확정 기록 — 눈금 통일 근거 + 인지된 트레이드오프(저사용 구간 ★5 수렴 → 원값 병기로 변별) 명시. P95·최대 2케이스 병행 규칙 불변
- 별점 재환산 (측정값 불변): pool P95 48.2% ★1→★3 · P6 P95 1.32% ★4→★5 · P6 최대 4.0% ★3→★5 (seq2 ★5·pool 최대 ★0 불변) — 63/65/66/61 및 breakdowns 재파생
- drawio 61-3 사다리 문구 20%p로 재수출, 61/65 PPT 재생성 (각 14슬라이드), 테스트 183건 통과 (경계 포함·중간 칸 확인 지점 추가)

Co-Authored-By: Claude Fable 5 <noreply@anthropic.com>
</commit_message>
<xml_diff>
--- a/docs/changbae/61-핵심QA-5종-임원-브리핑.pptx
+++ b/docs/changbae/61-핵심QA-5종-임원-브리핑.pptx
@@ -795,7 +795,7 @@
           <a:lstStyle/>
           <a:p>
             <a:r>
-              <a:t>한도 유도: 플래그십 단말 전형의 앱 힙 상한 256MB × 75%(GC 여유 25% 차감) − 64MB(협상 외 앱 기본 점유, 잠정 — 실측 대체 예정) = 128MB. 로그 사다리 개정 근거: 선형 15%p 등분은 실측에서 4-16축 전부 ★5 → 20축 절벽으로 포화 (24 §2.8). 실측 표본: composite 정본 FIN 500건 (63번 문서).</a:t>
+              <a:t>한도 유도: 플래그십 단말 전형의 앱 힙 상한 256MB × 75%(GC 여유 25% 차감) − 64MB(협상 외 앱 기본 점유, 잠정 — 실측 대체 예정) = 128MB. 사다리 근거: 20%p 등분으로 시간·기밀성과 눈금 통일 (24 §2.8 확정 — r가 자릿수로 퍼져 저사용 구간이 ★5에 모이는 트레이드오프는 원값 병기로 보완). 실측 표본: composite 정본 FIN 500건 (63번 문서).</a:t>
             </a:r>
           </a:p>
         </p:txBody>
@@ -6865,7 +6865,7 @@
                 </a:solidFill>
                 <a:latin typeface="맑은 고딕"/>
               </a:rPr>
-              <a:t>별점 = P95·최대 2케이스 병행 (① 꼬리 여유 ② 최악 안전 — 단일 인용 대표는 최대) · 사다리 = [1%,100%] 로그 4등분</a:t>
+              <a:t>별점 = P95·최대 2케이스 병행 (① 꼬리 여유 ② 최악 안전 — 단일 인용 대표는 최대) · 사다리 = 20%p 등분 (시간·기밀성과 동일 눈금)</a:t>
             </a:r>
           </a:p>
           <a:p>
@@ -7145,7 +7145,7 @@
                           </a:solidFill>
                           <a:latin typeface="맑은 고딕"/>
                         </a:rPr>
-                        <a:t>≤1%</a:t>
+                        <a:t>≤20%</a:t>
                       </a:r>
                     </a:p>
                   </a:txBody>
@@ -7168,7 +7168,7 @@
                           </a:solidFill>
                           <a:latin typeface="맑은 고딕"/>
                         </a:rPr>
-                        <a:t>≤3.2%</a:t>
+                        <a:t>≤40%</a:t>
                       </a:r>
                     </a:p>
                   </a:txBody>
@@ -7191,7 +7191,7 @@
                           </a:solidFill>
                           <a:latin typeface="맑은 고딕"/>
                         </a:rPr>
-                        <a:t>≤10%</a:t>
+                        <a:t>≤60%</a:t>
                       </a:r>
                     </a:p>
                   </a:txBody>
@@ -7214,7 +7214,7 @@
                           </a:solidFill>
                           <a:latin typeface="맑은 고딕"/>
                         </a:rPr>
-                        <a:t>≤32%</a:t>
+                        <a:t>≤80%</a:t>
                       </a:r>
                     </a:p>
                   </a:txBody>
@@ -7325,7 +7325,7 @@
                 </a:solidFill>
                 <a:latin typeface="맑은 고딕"/>
               </a:rPr>
-              <a:t>[1%,100%] 로그 4등분 — ★5 = 실사용 최대까지 성장(약 100배) 여유 (24 §2.8 재개정 2026-08-14)</a:t>
+              <a:t>20%p 등분 — 시간·기밀성 사다리와 동일 눈금 · 저사용 변별은 원값 병기 (24 §2.8 확정 2026-08-14)</a:t>
             </a:r>
           </a:p>
         </p:txBody>
@@ -7407,7 +7407,7 @@
                 </a:solidFill>
                 <a:latin typeface="맑은 고딕"/>
               </a:rPr>
-              <a:t>  vs  pool  P95 48.2% ★1 · 최대 3,692% ★0</a:t>
+              <a:t>  vs  pool  P95 48.2% ★3 · 최대 3,692% ★0</a:t>
             </a:r>
           </a:p>
           <a:p>

</xml_diff>

<commit_message>
feat(24,total),docs(60,61,62,64,65): CF 별점 3차 재개정 — 실측 앵커 등분 (PL 확정)
사다리 기준을 수학 등분(20%p)에서 실측 프로토콜 앵커 2점으로 교체:
naive SAOP 실측 노출 66% = ★2 · 1:1 실측 30%(e₂ ext2) = ★4, 18%p 등간격
→ ≤12★5 / ≤30★4 / ≤48★3 / ≤66★2 / ≤84★1 / >84★0 (경계 포함 ≤).
별점 이동: 1-A 31.7% ★4→★3 (앵커 직상 1.7%p) · 방안2 48.3% ★3→★2
(경계 0.3%p 밖) · 방안2+ 7.9% ★5 유지. 24 §3.3·§0 + band_cf_exposure +
테스트(111 통과) + 종속 문서 5종 md·PPT 2종 별점 일괄 동기화.

Co-Authored-By: Claude Fable 5 <noreply@anthropic.com>
Claude-Session: https://claude.ai/code/session_0146pfmbkimXRkUt6XgiasYd
</commit_message>
<xml_diff>
--- a/docs/changbae/61-핵심QA-5종-임원-브리핑.pptx
+++ b/docs/changbae/61-핵심QA-5종-임원-브리핑.pptx
@@ -6865,7 +6865,7 @@
                 </a:solidFill>
                 <a:latin typeface="맑은 고딕"/>
               </a:rPr>
-              <a:t>별점 = P95·최대 2케이스 병행 (① 꼬리 여유 ② 최악 안전 — 단일 인용 대표는 최대) · 사다리 = 20%p 등분 (시간·기밀성과 동일 눈금)</a:t>
+              <a:t>별점 = P95·최대 2케이스 병행 (① 꼬리 여유 ② 최악 안전 — 단일 인용 대표는 최대) · 사다리 = 20%p 등분 (시간과 동일 눈금 — 기밀성은 실측 앵커 등분, 3차)</a:t>
             </a:r>
           </a:p>
           <a:p>
@@ -7325,7 +7325,7 @@
                 </a:solidFill>
                 <a:latin typeface="맑은 고딕"/>
               </a:rPr>
-              <a:t>20%p 등분 — 시간·기밀성 사다리와 동일 눈금 · 저사용 변별은 원값 병기 (24 §2.8 확정 2026-08-14)</a:t>
+              <a:t>20%p 등분 — 시간 사다리와 동일 눈금 · 저사용 변별은 원값 병기 (24 §2.8 확정 2026-08-14)</a:t>
             </a:r>
           </a:p>
         </p:txBody>
@@ -8084,7 +8084,7 @@
                           </a:solidFill>
                           <a:latin typeface="맑은 고딕"/>
                         </a:rPr>
-                        <a:t>≤20%</a:t>
+                        <a:t>≤12%</a:t>
                       </a:r>
                     </a:p>
                   </a:txBody>
@@ -8107,7 +8107,7 @@
                           </a:solidFill>
                           <a:latin typeface="맑은 고딕"/>
                         </a:rPr>
-                        <a:t>≤40%</a:t>
+                        <a:t>≤30%</a:t>
                       </a:r>
                     </a:p>
                   </a:txBody>
@@ -8130,7 +8130,7 @@
                           </a:solidFill>
                           <a:latin typeface="맑은 고딕"/>
                         </a:rPr>
-                        <a:t>≤60%</a:t>
+                        <a:t>≤48%</a:t>
                       </a:r>
                     </a:p>
                   </a:txBody>
@@ -8153,7 +8153,7 @@
                           </a:solidFill>
                           <a:latin typeface="맑은 고딕"/>
                         </a:rPr>
-                        <a:t>≤80%</a:t>
+                        <a:t>≤66%</a:t>
                       </a:r>
                     </a:p>
                   </a:txBody>
@@ -8176,7 +8176,7 @@
                           </a:solidFill>
                           <a:latin typeface="맑은 고딕"/>
                         </a:rPr>
-                        <a:t>&lt;100%</a:t>
+                        <a:t>≤84%</a:t>
                       </a:r>
                     </a:p>
                   </a:txBody>
@@ -8199,7 +8199,7 @@
                           </a:solidFill>
                           <a:latin typeface="맑은 고딕"/>
                         </a:rPr>
-                        <a:t>100%</a:t>
+                        <a:t>&gt;84%</a:t>
                       </a:r>
                     </a:p>
                   </a:txBody>
@@ -8264,7 +8264,7 @@
                 </a:solidFill>
                 <a:latin typeface="맑은 고딕"/>
               </a:rPr>
-              <a:t>무노출 0%와 전량 공개 100% 사이 20%p 등분 (경계 포함 — TB·RU와 동일 규약) · 1:1 협상 실측 노출 29.2% = ★4 구간</a:t>
+              <a:t>실측 앵커 등분 (3차): 1:1 협상 실측 30%(e₂) = ★4 · naive SAOP 실측 66% = ★2, 18%p 등간격 (경계 포함 ≤)</a:t>
             </a:r>
           </a:p>
         </p:txBody>
@@ -8337,7 +8337,7 @@
                 </a:solidFill>
                 <a:latin typeface="맑은 고딕"/>
               </a:rPr>
-              <a:t>방안 1-A  노출 31.7% ★4</a:t>
+              <a:t>방안 1-A  노출 31.7% ★3</a:t>
             </a:r>
             <a:r>
               <a:rPr sz="1400" b="1">
@@ -8346,7 +8346,7 @@
                 </a:solidFill>
                 <a:latin typeface="맑은 고딕"/>
               </a:rPr>
-              <a:t>  vs  방안 2  48.3% ★3</a:t>
+              <a:t>  vs  방안 2  48.3% ★2</a:t>
             </a:r>
           </a:p>
           <a:p>
@@ -8378,7 +8378,7 @@
                 </a:solidFill>
                 <a:latin typeface="맑은 고딕"/>
               </a:rPr>
-              <a:t>1-A는 1:1 협상 수준(29.2%)에 근접 · 방안 2는 합의 후보가 깊은 판에서 노출 70%까지 상승</a:t>
+              <a:t>1-A는 1:1 앵커(30%) 직상 1.7%p · 방안 2는 ★3 경계(48%) 0.3%p 밖 — 깊은 판에서 노출 70%까지 상승</a:t>
             </a:r>
           </a:p>
           <a:p>
@@ -10807,7 +10807,7 @@
                           </a:solidFill>
                           <a:latin typeface="맑은 고딕"/>
                         </a:rPr>
-                        <a:t>★4</a:t>
+                        <a:t>★3</a:t>
                       </a:r>
                     </a:p>
                   </a:txBody>
@@ -10830,7 +10830,7 @@
                           </a:solidFill>
                           <a:latin typeface="맑은 고딕"/>
                         </a:rPr>
-                        <a:t>★3</a:t>
+                        <a:t>★2</a:t>
                       </a:r>
                     </a:p>
                   </a:txBody>

</xml_diff>

<commit_message>
qa(ru)+docs: RU 사다리 [1%,100%] 로그 4등분 최종 복귀 + 70·71 T 통계·축별 시간 그래프 추가 (PL 지시 2026-08-14)
- RU 사다리: 20%p 등분 → 로그 복귀 (FIN2 보고에서 저사용 변별 상실 실측 확인 — 24 §2.8 이력 4차 기록, 구 20%p는 band_ru_usage_20pp 보존). constants·집계기·테스트·breakdowns 재파생
- 별점 재환산 전 문서: 63(pool P95 ★1)·66(P6 ★4/★3)·65·61(사다리 표·발표노트)·drawio 61-3·PPT 2종 재생성 / 70(pool ★1·seq2 최대 ★4)·71(P6 ★4/★3 — seq2 대비 한 칸 열세로 결론 재작성)
- 70 F3·71 §4.2: T 통계표(최소/평균/중앙/P95/최대 — naive 병기, 카테고리별) 신설. naive 평균≫중앙(극단 꼬리) 주의 명시
- scripts/plot_time_by_axis.py 신설 → figures/70/fig-time-by-axis.png (CR/RS 패널, 중앙 실선+P95 점선, naive·seq2·pool·P6 4계열) — 70 E-1·71 §4.2 삽입

Co-Authored-By: Claude Fable 5 <noreply@anthropic.com>
</commit_message>
<xml_diff>
--- a/docs/changbae/61-핵심QA-5종-임원-브리핑.pptx
+++ b/docs/changbae/61-핵심QA-5종-임원-브리핑.pptx
@@ -795,7 +795,7 @@
           <a:lstStyle/>
           <a:p>
             <a:r>
-              <a:t>한도 유도: 플래그십 단말 전형의 앱 힙 상한 256MB × 75%(GC 여유 25% 차감) − 64MB(협상 외 앱 기본 점유, 잠정 — 실측 대체 예정) = 128MB. 사다리 근거: 20%p 등분으로 시간·기밀성과 눈금 통일 (24 §2.8 확정 — r가 자릿수로 퍼져 저사용 구간이 ★5에 모이는 트레이드오프는 원값 병기로 보완). 실측 표본: composite 정본 FIN 500건 (63번 문서).</a:t>
+              <a:t>한도 유도: 플래그십 단말 전형의 앱 힙 상한 256MB × 75%(GC 여유 25% 차감) − 64MB(협상 외 앱 기본 점유, 잠정 — 실측 대체 예정) = 128MB. 사다리 근거: r가 자릿수로 퍼지는 지표라 로그 눈금이 실측을 변별 — ★5 = 1%는 실사용 최대까지의 성장 배수(약 100배)에서 유도 (24 §2.8 최종 — 20%p 등분은 저사용 변별 상실로 복귀). 실측 표본: composite 정본 FIN 500건 (63번 문서).</a:t>
             </a:r>
           </a:p>
         </p:txBody>
@@ -6865,7 +6865,7 @@
                 </a:solidFill>
                 <a:latin typeface="맑은 고딕"/>
               </a:rPr>
-              <a:t>별점 = P95·최대 2케이스 병행 (① 꼬리 여유 ② 최악 안전 — 단일 인용 대표는 최대) · 사다리 = 20%p 등분 (시간과 동일 눈금 — 기밀성은 실측 앵커 등분, 3차)</a:t>
+              <a:t>별점 = P95·최대 2케이스 병행 (① 꼬리 여유 ② 최악 안전 — 단일 인용 대표는 최대) · 사다리 = [1%,100%] 로그 4등분 (20%p에서 복귀 — 저사용 변별)</a:t>
             </a:r>
           </a:p>
           <a:p>
@@ -7145,7 +7145,7 @@
                           </a:solidFill>
                           <a:latin typeface="맑은 고딕"/>
                         </a:rPr>
-                        <a:t>≤20%</a:t>
+                        <a:t>≤1%</a:t>
                       </a:r>
                     </a:p>
                   </a:txBody>
@@ -7168,7 +7168,7 @@
                           </a:solidFill>
                           <a:latin typeface="맑은 고딕"/>
                         </a:rPr>
-                        <a:t>≤40%</a:t>
+                        <a:t>≤3.2%</a:t>
                       </a:r>
                     </a:p>
                   </a:txBody>
@@ -7191,7 +7191,7 @@
                           </a:solidFill>
                           <a:latin typeface="맑은 고딕"/>
                         </a:rPr>
-                        <a:t>≤60%</a:t>
+                        <a:t>≤10%</a:t>
                       </a:r>
                     </a:p>
                   </a:txBody>
@@ -7214,7 +7214,7 @@
                           </a:solidFill>
                           <a:latin typeface="맑은 고딕"/>
                         </a:rPr>
-                        <a:t>≤80%</a:t>
+                        <a:t>≤32%</a:t>
                       </a:r>
                     </a:p>
                   </a:txBody>
@@ -7325,7 +7325,7 @@
                 </a:solidFill>
                 <a:latin typeface="맑은 고딕"/>
               </a:rPr>
-              <a:t>20%p 등분 — 시간 사다리와 동일 눈금 · 저사용 변별은 원값 병기 (24 §2.8 확정 2026-08-14)</a:t>
+              <a:t>[1%,100%] 로그 4등분 — ★5 = 실사용 최대까지 성장(약 100배) 여유, 1칸 = √10 ≈ 3.2배 (24 §2.8 최종 2026-08-14)</a:t>
             </a:r>
           </a:p>
         </p:txBody>
@@ -8084,7 +8084,7 @@
                           </a:solidFill>
                           <a:latin typeface="맑은 고딕"/>
                         </a:rPr>
-                        <a:t>≤12%</a:t>
+                        <a:t>≤20%</a:t>
                       </a:r>
                     </a:p>
                   </a:txBody>
@@ -8107,7 +8107,7 @@
                           </a:solidFill>
                           <a:latin typeface="맑은 고딕"/>
                         </a:rPr>
-                        <a:t>≤30%</a:t>
+                        <a:t>≤40%</a:t>
                       </a:r>
                     </a:p>
                   </a:txBody>
@@ -8130,7 +8130,7 @@
                           </a:solidFill>
                           <a:latin typeface="맑은 고딕"/>
                         </a:rPr>
-                        <a:t>≤48%</a:t>
+                        <a:t>≤60%</a:t>
                       </a:r>
                     </a:p>
                   </a:txBody>
@@ -8153,7 +8153,7 @@
                           </a:solidFill>
                           <a:latin typeface="맑은 고딕"/>
                         </a:rPr>
-                        <a:t>≤66%</a:t>
+                        <a:t>≤80%</a:t>
                       </a:r>
                     </a:p>
                   </a:txBody>
@@ -8176,7 +8176,7 @@
                           </a:solidFill>
                           <a:latin typeface="맑은 고딕"/>
                         </a:rPr>
-                        <a:t>≤84%</a:t>
+                        <a:t>&lt;100%</a:t>
                       </a:r>
                     </a:p>
                   </a:txBody>
@@ -8199,7 +8199,7 @@
                           </a:solidFill>
                           <a:latin typeface="맑은 고딕"/>
                         </a:rPr>
-                        <a:t>&gt;84%</a:t>
+                        <a:t>100%</a:t>
                       </a:r>
                     </a:p>
                   </a:txBody>
@@ -8264,7 +8264,7 @@
                 </a:solidFill>
                 <a:latin typeface="맑은 고딕"/>
               </a:rPr>
-              <a:t>실측 앵커 등분 (3차): 1:1 협상 실측 30%(e₂) = ★4 · naive SAOP 실측 66% = ★2, 18%p 등간격 (경계 포함 ≤)</a:t>
+              <a:t>무노출 0%와 전량 공개 100% 사이 20%p 등분 (경계 포함 — TB·RU와 동일 규약) · 1:1 협상 실측 노출 29.2% = ★4 구간</a:t>
             </a:r>
           </a:p>
         </p:txBody>
@@ -8337,7 +8337,7 @@
                 </a:solidFill>
                 <a:latin typeface="맑은 고딕"/>
               </a:rPr>
-              <a:t>방안 1-A  노출 31.7% ★3</a:t>
+              <a:t>방안 1-A  노출 31.7% ★4</a:t>
             </a:r>
             <a:r>
               <a:rPr sz="1400" b="1">
@@ -8346,7 +8346,7 @@
                 </a:solidFill>
                 <a:latin typeface="맑은 고딕"/>
               </a:rPr>
-              <a:t>  vs  방안 2  48.3% ★2</a:t>
+              <a:t>  vs  방안 2  48.3% ★3</a:t>
             </a:r>
           </a:p>
           <a:p>
@@ -8378,7 +8378,7 @@
                 </a:solidFill>
                 <a:latin typeface="맑은 고딕"/>
               </a:rPr>
-              <a:t>1-A는 1:1 앵커(30%) 직상 1.7%p · 방안 2는 ★3 경계(48%) 0.3%p 밖 — 깊은 판에서 노출 70%까지 상승</a:t>
+              <a:t>1-A는 1:1 협상 수준(29.2%)에 근접 · 방안 2는 합의 후보가 깊은 판에서 노출 70%까지 상승</a:t>
             </a:r>
           </a:p>
           <a:p>
@@ -10807,7 +10807,7 @@
                           </a:solidFill>
                           <a:latin typeface="맑은 고딕"/>
                         </a:rPr>
-                        <a:t>★3</a:t>
+                        <a:t>★4</a:t>
                       </a:r>
                     </a:p>
                   </a:txBody>
@@ -10830,7 +10830,7 @@
                           </a:solidFill>
                           <a:latin typeface="맑은 고딕"/>
                         </a:rPr>
-                        <a:t>★2</a:t>
+                        <a:t>★3</a:t>
                       </a:r>
                     </a:p>
                   </a:txBody>

</xml_diff>